<commit_message>
style: set typography to Times New Roman across presentation assets
</commit_message>
<xml_diff>
--- a/DocIntel_Development_Approach.pptx
+++ b/DocIntel_Development_Approach.pptx
@@ -13,7 +13,6 @@
     <p:sldId id="261" r:id="rId12"/>
     <p:sldId id="262" r:id="rId13"/>
     <p:sldId id="263" r:id="rId14"/>
-    <p:sldId id="264" r:id="rId15"/>
   </p:sldIdLst>
   <p:sldSz cx="12191695" cy="6858000" type="screen4x3"/>
   <p:notesSz cx="6858000" cy="9144000"/>
@@ -3111,7 +3110,7 @@
             <a:avLst/>
           </a:prstGeom>
           <a:solidFill>
-            <a:srgbClr val="0A0E17"/>
+            <a:srgbClr val="0B0F19"/>
           </a:solidFill>
           <a:ln>
             <a:noFill/>
@@ -3147,8 +3146,8 @@
         </p:nvSpPr>
         <p:spPr>
           <a:xfrm>
-            <a:off x="914400" y="1097280"/>
-            <a:ext cx="3108960" cy="329184"/>
+            <a:off x="914400" y="1005840"/>
+            <a:ext cx="3291840" cy="329184"/>
           </a:xfrm>
           <a:prstGeom prst="roundRect">
             <a:avLst/>
@@ -3183,10 +3182,11 @@
                 <a:solidFill>
                   <a:srgbClr val="93C5FD"/>
                 </a:solidFill>
-              </a:defRPr>
-            </a:pPr>
-            <a:r>
-              <a:t>FULL-STACK AI &amp; BACKEND PROJECT</a:t>
+                <a:latin typeface="Times New Roman"/>
+              </a:defRPr>
+            </a:pPr>
+            <a:r>
+              <a:t>EXECUTIVE TECHNICAL ASSESSMENT</a:t>
             </a:r>
           </a:p>
         </p:txBody>
@@ -3199,7 +3199,7 @@
         </p:nvSpPr>
         <p:spPr>
           <a:xfrm>
-            <a:off x="914400" y="1600200"/>
+            <a:off x="914400" y="1508760"/>
             <a:ext cx="10332720" cy="2011680"/>
           </a:xfrm>
           <a:prstGeom prst="rect">
@@ -3217,10 +3217,11 @@
               <a:spcAft>
                 <a:spcPts val="800"/>
               </a:spcAft>
-              <a:defRPr sz="3000" b="1">
-                <a:solidFill>
-                  <a:srgbClr val="F8FAFC"/>
-                </a:solidFill>
+              <a:defRPr sz="3200" b="1">
+                <a:solidFill>
+                  <a:srgbClr val="F8FAFC"/>
+                </a:solidFill>
+                <a:latin typeface="Times New Roman"/>
               </a:defRPr>
             </a:pPr>
             <a:r>
@@ -3229,14 +3230,15 @@
           </a:p>
           <a:p>
             <a:pPr>
-              <a:defRPr sz="1600">
+              <a:defRPr sz="1650">
                 <a:solidFill>
                   <a:srgbClr val="94A3B8"/>
                 </a:solidFill>
-              </a:defRPr>
-            </a:pPr>
-            <a:r>
-              <a:t>Deterministic Accounting Validation, Zero-Dependency OCR, and Grounded Provenance Citations</a:t>
+                <a:latin typeface="Times New Roman"/>
+              </a:defRPr>
+            </a:pPr>
+            <a:r>
+              <a:t>Deterministic Accounting Invariants, Zero-Dependency OCR &amp; Grounded Provenance Citations</a:t>
             </a:r>
           </a:p>
         </p:txBody>
@@ -3249,8 +3251,8 @@
         </p:nvSpPr>
         <p:spPr>
           <a:xfrm>
-            <a:off x="914400" y="3840480"/>
-            <a:ext cx="10332720" cy="2286000"/>
+            <a:off x="914400" y="3749039"/>
+            <a:ext cx="10332720" cy="2377440"/>
           </a:xfrm>
           <a:prstGeom prst="roundRect">
             <a:avLst/>
@@ -3294,8 +3296,8 @@
         </p:nvSpPr>
         <p:spPr>
           <a:xfrm>
-            <a:off x="1188720" y="4023360"/>
-            <a:ext cx="9784080" cy="1920240"/>
+            <a:off x="1188720" y="3931920"/>
+            <a:ext cx="9784080" cy="2011680"/>
           </a:xfrm>
           <a:prstGeom prst="rect">
             <a:avLst/>
@@ -3316,10 +3318,11 @@
                 <a:solidFill>
                   <a:srgbClr val="F8FAFC"/>
                 </a:solidFill>
-              </a:defRPr>
-            </a:pPr>
-            <a:r>
-              <a:t>Candidate / Engineer      :  Swathi Karunakaran</a:t>
+                <a:latin typeface="Times New Roman"/>
+              </a:defRPr>
+            </a:pPr>
+            <a:r>
+              <a:t>Candidate / Lead Engineer  :  Swathi Karunakaran</a:t>
             </a:r>
           </a:p>
           <a:p>
@@ -3331,10 +3334,11 @@
                 <a:solidFill>
                   <a:srgbClr val="38BDF8"/>
                 </a:solidFill>
-              </a:defRPr>
-            </a:pPr>
-            <a:r>
-              <a:t>Live Cloud Deployment     :  https://doc-intel-financial-platform.onrender.com/ (Render Cloud)</a:t>
+                <a:latin typeface="Times New Roman"/>
+              </a:defRPr>
+            </a:pPr>
+            <a:r>
+              <a:t>Live Cloud Deployment      :  https://doc-intel-financial-platform.onrender.com/ (Render Cloud)</a:t>
             </a:r>
           </a:p>
           <a:p>
@@ -3346,10 +3350,11 @@
                 <a:solidFill>
                   <a:srgbClr val="F8FAFC"/>
                 </a:solidFill>
-              </a:defRPr>
-            </a:pPr>
-            <a:r>
-              <a:t>Public GitHub Repository  :  https://github.com/swathikarunakaran11-bit/doc-intel-financial-platform</a:t>
+                <a:latin typeface="Times New Roman"/>
+              </a:defRPr>
+            </a:pPr>
+            <a:r>
+              <a:t>Public GitHub Repository   :  https://github.com/swathikarunakaran11-bit/doc-intel-financial-platform</a:t>
             </a:r>
           </a:p>
           <a:p>
@@ -3361,10 +3366,11 @@
                 <a:solidFill>
                   <a:srgbClr val="F8FAFC"/>
                 </a:solidFill>
-              </a:defRPr>
-            </a:pPr>
-            <a:r>
-              <a:t>Architectural Stack       :  FastAPI (Python 3.11), RapidOCR (ONNX Runtime), pypdfium2, Docker, SQLite/Postgres</a:t>
+                <a:latin typeface="Times New Roman"/>
+              </a:defRPr>
+            </a:pPr>
+            <a:r>
+              <a:t>Architectural Stack        :  Python 3.11, FastAPI, RapidOCR (ONNX Runtime), pypdfium2, Docker, SQLAlchemy</a:t>
             </a:r>
           </a:p>
           <a:p>
@@ -3376,10 +3382,11 @@
                 <a:solidFill>
                   <a:srgbClr val="F8FAFC"/>
                 </a:solidFill>
-              </a:defRPr>
-            </a:pPr>
-            <a:r>
-              <a:t>Empirical Validation Scope:  50 Real-World Documents Benchmark (100% Extraction, 95.4% Mean Confidence)</a:t>
+                <a:latin typeface="Times New Roman"/>
+              </a:defRPr>
+            </a:pPr>
+            <a:r>
+              <a:t>Validation Scope           :  50 Real-World Documents Processed (100% Extraction Rate · 95.4% Mean Confidence)</a:t>
             </a:r>
           </a:p>
           <a:p>
@@ -3391,10 +3398,11 @@
                 <a:solidFill>
                   <a:srgbClr val="F8FAFC"/>
                 </a:solidFill>
-              </a:defRPr>
-            </a:pPr>
-            <a:r>
-              <a:t>Quality Assurance         :  10/10 Automated Pytest Suite Passing (100% Core Endpoint &amp; Math Invariant Coverage)</a:t>
+                <a:latin typeface="Times New Roman"/>
+              </a:defRPr>
+            </a:pPr>
+            <a:r>
+              <a:t>Quality Assurance          :  10/10 Passing Automated Pytest Suite (100% Invariant &amp; API Coverage)</a:t>
             </a:r>
           </a:p>
         </p:txBody>
@@ -3432,7 +3440,7 @@
             <a:avLst/>
           </a:prstGeom>
           <a:solidFill>
-            <a:srgbClr val="0A0E17"/>
+            <a:srgbClr val="0B0F19"/>
           </a:solidFill>
           <a:ln>
             <a:noFill/>
@@ -3500,10 +3508,11 @@
           <a:lstStyle/>
           <a:p>
             <a:pPr algn="ctr">
-              <a:defRPr sz="950" b="1">
+              <a:defRPr sz="1000" b="1">
                 <a:solidFill>
                   <a:srgbClr val="93C5FD"/>
                 </a:solidFill>
+                <a:latin typeface="Times New Roman"/>
               </a:defRPr>
             </a:pPr>
             <a:r>
@@ -3535,10 +3544,11 @@
           <a:lstStyle/>
           <a:p>
             <a:pPr>
-              <a:defRPr sz="2100" b="1">
-                <a:solidFill>
-                  <a:srgbClr val="F8FAFC"/>
-                </a:solidFill>
+              <a:defRPr sz="2200" b="1">
+                <a:solidFill>
+                  <a:srgbClr val="F8FAFC"/>
+                </a:solidFill>
+                <a:latin typeface="Times New Roman"/>
               </a:defRPr>
             </a:pPr>
             <a:r>
@@ -3570,14 +3580,15 @@
           <a:lstStyle/>
           <a:p>
             <a:pPr algn="r">
-              <a:defRPr sz="1100" b="1">
+              <a:defRPr sz="1200" b="1">
                 <a:solidFill>
                   <a:srgbClr val="94A3B8"/>
                 </a:solidFill>
-              </a:defRPr>
-            </a:pPr>
-            <a:r>
-              <a:t>02/09</a:t>
+                <a:latin typeface="Times New Roman"/>
+              </a:defRPr>
+            </a:pPr>
+            <a:r>
+              <a:t>02/08</a:t>
             </a:r>
           </a:p>
         </p:txBody>
@@ -3653,10 +3664,11 @@
               <a:spcAft>
                 <a:spcPts val="800"/>
               </a:spcAft>
-              <a:defRPr sz="1400" b="1">
+              <a:defRPr sz="1500" b="1">
                 <a:solidFill>
                   <a:srgbClr val="F87171"/>
                 </a:solidFill>
+                <a:latin typeface="Times New Roman"/>
               </a:defRPr>
             </a:pPr>
             <a:r>
@@ -3668,59 +3680,63 @@
               <a:spcAft>
                 <a:spcPts val="500"/>
               </a:spcAft>
-              <a:defRPr sz="1150">
-                <a:solidFill>
-                  <a:srgbClr val="F8FAFC"/>
-                </a:solidFill>
-              </a:defRPr>
-            </a:pPr>
-            <a:r>
-              <a:t>• Fixed-coordinate bounding boxes break when vendors change margins or DPI resolutions.</a:t>
-            </a:r>
-          </a:p>
-          <a:p>
-            <a:pPr>
-              <a:spcAft>
-                <a:spcPts val="500"/>
-              </a:spcAft>
-              <a:defRPr sz="1150">
-                <a:solidFill>
-                  <a:srgbClr val="F8FAFC"/>
-                </a:solidFill>
-              </a:defRPr>
-            </a:pPr>
-            <a:r>
-              <a:t>• Fails on skewed scans, multi-page tables, or non-standard multi-column layouts.</a:t>
-            </a:r>
-          </a:p>
-          <a:p>
-            <a:pPr>
-              <a:spcAft>
-                <a:spcPts val="500"/>
-              </a:spcAft>
-              <a:defRPr sz="1150">
-                <a:solidFill>
-                  <a:srgbClr val="F8FAFC"/>
-                </a:solidFill>
-              </a:defRPr>
-            </a:pPr>
-            <a:r>
-              <a:t>• High maintenance cost: writing and debugging bespoke regex rules that constantly drift.</a:t>
-            </a:r>
-          </a:p>
-          <a:p>
-            <a:pPr>
-              <a:spcAft>
-                <a:spcPts val="500"/>
-              </a:spcAft>
-              <a:defRPr sz="1150">
-                <a:solidFill>
-                  <a:srgbClr val="F8FAFC"/>
-                </a:solidFill>
-              </a:defRPr>
-            </a:pPr>
-            <a:r>
-              <a:t>• Zero concept of mathematical consistency or financial validation.</a:t>
+              <a:defRPr sz="1200">
+                <a:solidFill>
+                  <a:srgbClr val="F8FAFC"/>
+                </a:solidFill>
+                <a:latin typeface="Times New Roman"/>
+              </a:defRPr>
+            </a:pPr>
+            <a:r>
+              <a:t>• Fixed-coordinate bounding boxes break when vendors adjust margins, line spacing, or DPIs.</a:t>
+            </a:r>
+          </a:p>
+          <a:p>
+            <a:pPr>
+              <a:spcAft>
+                <a:spcPts val="500"/>
+              </a:spcAft>
+              <a:defRPr sz="1200">
+                <a:solidFill>
+                  <a:srgbClr val="F8FAFC"/>
+                </a:solidFill>
+                <a:latin typeface="Times New Roman"/>
+              </a:defRPr>
+            </a:pPr>
+            <a:r>
+              <a:t>• Cannot parse rotated scans, multi-page flows, or dynamic financial table grids.</a:t>
+            </a:r>
+          </a:p>
+          <a:p>
+            <a:pPr>
+              <a:spcAft>
+                <a:spcPts val="500"/>
+              </a:spcAft>
+              <a:defRPr sz="1200">
+                <a:solidFill>
+                  <a:srgbClr val="F8FAFC"/>
+                </a:solidFill>
+                <a:latin typeface="Times New Roman"/>
+              </a:defRPr>
+            </a:pPr>
+            <a:r>
+              <a:t>• High engineering liability: constantly writing custom regex that inevitably drifts.</a:t>
+            </a:r>
+          </a:p>
+          <a:p>
+            <a:pPr>
+              <a:spcAft>
+                <a:spcPts val="500"/>
+              </a:spcAft>
+              <a:defRPr sz="1200">
+                <a:solidFill>
+                  <a:srgbClr val="F8FAFC"/>
+                </a:solidFill>
+                <a:latin typeface="Times New Roman"/>
+              </a:defRPr>
+            </a:pPr>
+            <a:r>
+              <a:t>• Zero understanding of mathematical consistency or balance sheet integrity.</a:t>
             </a:r>
           </a:p>
         </p:txBody>
@@ -3796,40 +3812,43 @@
               <a:spcAft>
                 <a:spcPts val="800"/>
               </a:spcAft>
-              <a:defRPr sz="1400" b="1">
+              <a:defRPr sz="1500" b="1">
                 <a:solidFill>
                   <a:srgbClr val="F87171"/>
                 </a:solidFill>
-              </a:defRPr>
-            </a:pPr>
-            <a:r>
-              <a:t>2. Blind LLM Extraction (GPT-4)  · [Hallucinatory]</a:t>
-            </a:r>
-          </a:p>
-          <a:p>
-            <a:pPr>
-              <a:spcAft>
-                <a:spcPts val="500"/>
-              </a:spcAft>
-              <a:defRPr sz="1150">
-                <a:solidFill>
-                  <a:srgbClr val="F8FAFC"/>
-                </a:solidFill>
-              </a:defRPr>
-            </a:pPr>
-            <a:r>
-              <a:t>• Financial Hallucinations: Plausibly fabricates numbers not present in the source PDF.</a:t>
-            </a:r>
-          </a:p>
-          <a:p>
-            <a:pPr>
-              <a:spcAft>
-                <a:spcPts val="500"/>
-              </a:spcAft>
-              <a:defRPr sz="1150">
-                <a:solidFill>
-                  <a:srgbClr val="F8FAFC"/>
-                </a:solidFill>
+                <a:latin typeface="Times New Roman"/>
+              </a:defRPr>
+            </a:pPr>
+            <a:r>
+              <a:t>2. Blind LLM Extractions (GPT-4)  · [Hallucinatory]</a:t>
+            </a:r>
+          </a:p>
+          <a:p>
+            <a:pPr>
+              <a:spcAft>
+                <a:spcPts val="500"/>
+              </a:spcAft>
+              <a:defRPr sz="1200">
+                <a:solidFill>
+                  <a:srgbClr val="F8FAFC"/>
+                </a:solidFill>
+                <a:latin typeface="Times New Roman"/>
+              </a:defRPr>
+            </a:pPr>
+            <a:r>
+              <a:t>• Financial Hallucinations: Plausibly fabricates figures absent from source filings.</a:t>
+            </a:r>
+          </a:p>
+          <a:p>
+            <a:pPr>
+              <a:spcAft>
+                <a:spcPts val="500"/>
+              </a:spcAft>
+              <a:defRPr sz="1200">
+                <a:solidFill>
+                  <a:srgbClr val="F8FAFC"/>
+                </a:solidFill>
+                <a:latin typeface="Times New Roman"/>
               </a:defRPr>
             </a:pPr>
             <a:r>
@@ -3841,29 +3860,31 @@
               <a:spcAft>
                 <a:spcPts val="500"/>
               </a:spcAft>
-              <a:defRPr sz="1150">
-                <a:solidFill>
-                  <a:srgbClr val="F8FAFC"/>
-                </a:solidFill>
-              </a:defRPr>
-            </a:pPr>
-            <a:r>
-              <a:t>• High Latency (8–15s per page) and recurring token fees ($0.05–$0.15/doc) at enterprise scale.</a:t>
-            </a:r>
-          </a:p>
-          <a:p>
-            <a:pPr>
-              <a:spcAft>
-                <a:spcPts val="500"/>
-              </a:spcAft>
-              <a:defRPr sz="1150">
-                <a:solidFill>
-                  <a:srgbClr val="F8FAFC"/>
-                </a:solidFill>
-              </a:defRPr>
-            </a:pPr>
-            <a:r>
-              <a:t>• Compliance Risk: Exposing confidential corporate financial data to third-party APIs.</a:t>
+              <a:defRPr sz="1200">
+                <a:solidFill>
+                  <a:srgbClr val="F8FAFC"/>
+                </a:solidFill>
+                <a:latin typeface="Times New Roman"/>
+              </a:defRPr>
+            </a:pPr>
+            <a:r>
+              <a:t>• High Latency &amp; Cost: 8–15s per page and recurring token fees at enterprise scale.</a:t>
+            </a:r>
+          </a:p>
+          <a:p>
+            <a:pPr>
+              <a:spcAft>
+                <a:spcPts val="500"/>
+              </a:spcAft>
+              <a:defRPr sz="1200">
+                <a:solidFill>
+                  <a:srgbClr val="F8FAFC"/>
+                </a:solidFill>
+                <a:latin typeface="Times New Roman"/>
+              </a:defRPr>
+            </a:pPr>
+            <a:r>
+              <a:t>• Regulatory Risk: Transmitting non-public financial records to external APIs violates SOX.</a:t>
             </a:r>
           </a:p>
         </p:txBody>
@@ -3939,10 +3960,11 @@
               <a:spcAft>
                 <a:spcPts val="800"/>
               </a:spcAft>
-              <a:defRPr sz="1400" b="1">
+              <a:defRPr sz="1500" b="1">
                 <a:solidFill>
                   <a:srgbClr val="34D399"/>
                 </a:solidFill>
+                <a:latin typeface="Times New Roman"/>
               </a:defRPr>
             </a:pPr>
             <a:r>
@@ -3954,10 +3976,11 @@
               <a:spcAft>
                 <a:spcPts val="500"/>
               </a:spcAft>
-              <a:defRPr sz="1150">
-                <a:solidFill>
-                  <a:srgbClr val="F8FAFC"/>
-                </a:solidFill>
+              <a:defRPr sz="1200">
+                <a:solidFill>
+                  <a:srgbClr val="F8FAFC"/>
+                </a:solidFill>
+                <a:latin typeface="Times New Roman"/>
               </a:defRPr>
             </a:pPr>
             <a:r>
@@ -3969,44 +3992,47 @@
               <a:spcAft>
                 <a:spcPts val="500"/>
               </a:spcAft>
-              <a:defRPr sz="1150">
-                <a:solidFill>
-                  <a:srgbClr val="F8FAFC"/>
-                </a:solidFill>
-              </a:defRPr>
-            </a:pPr>
-            <a:r>
-              <a:t>• Zero-Dependency Ingestion: Embedded ONNX Runtime OCR; no tesseract.exe or poppler binaries.</a:t>
-            </a:r>
-          </a:p>
-          <a:p>
-            <a:pPr>
-              <a:spcAft>
-                <a:spcPts val="500"/>
-              </a:spcAft>
-              <a:defRPr sz="1150">
-                <a:solidFill>
-                  <a:srgbClr val="F8FAFC"/>
-                </a:solidFill>
-              </a:defRPr>
-            </a:pPr>
-            <a:r>
-              <a:t>• Grounded Provenance: Every single number is tied to exact page and source text citations.</a:t>
-            </a:r>
-          </a:p>
-          <a:p>
-            <a:pPr>
-              <a:spcAft>
-                <a:spcPts val="500"/>
-              </a:spcAft>
-              <a:defRPr sz="1150">
-                <a:solidFill>
-                  <a:srgbClr val="F8FAFC"/>
-                </a:solidFill>
-              </a:defRPr>
-            </a:pPr>
-            <a:r>
-              <a:t>• Auditor-First UX: Dual-pane split-screen inspector cutting review time from minutes to seconds.</a:t>
+              <a:defRPr sz="1200">
+                <a:solidFill>
+                  <a:srgbClr val="F8FAFC"/>
+                </a:solidFill>
+                <a:latin typeface="Times New Roman"/>
+              </a:defRPr>
+            </a:pPr>
+            <a:r>
+              <a:t>• Zero-Dependency Ingestion: Embedded ONNX Runtime neural OCR; zero OS-level binaries.</a:t>
+            </a:r>
+          </a:p>
+          <a:p>
+            <a:pPr>
+              <a:spcAft>
+                <a:spcPts val="500"/>
+              </a:spcAft>
+              <a:defRPr sz="1200">
+                <a:solidFill>
+                  <a:srgbClr val="F8FAFC"/>
+                </a:solidFill>
+                <a:latin typeface="Times New Roman"/>
+              </a:defRPr>
+            </a:pPr>
+            <a:r>
+              <a:t>• Immutable Provenance: Every single number is tied to exact page and source text citations.</a:t>
+            </a:r>
+          </a:p>
+          <a:p>
+            <a:pPr>
+              <a:spcAft>
+                <a:spcPts val="500"/>
+              </a:spcAft>
+              <a:defRPr sz="1200">
+                <a:solidFill>
+                  <a:srgbClr val="F8FAFC"/>
+                </a:solidFill>
+                <a:latin typeface="Times New Roman"/>
+              </a:defRPr>
+            </a:pPr>
+            <a:r>
+              <a:t>• Auditor-First UX: Dual-pane split-screen inspector cutting review time by 90%.</a:t>
             </a:r>
           </a:p>
         </p:txBody>
@@ -4044,7 +4070,7 @@
             <a:avLst/>
           </a:prstGeom>
           <a:solidFill>
-            <a:srgbClr val="0A0E17"/>
+            <a:srgbClr val="0B0F19"/>
           </a:solidFill>
           <a:ln>
             <a:noFill/>
@@ -4112,10 +4138,11 @@
           <a:lstStyle/>
           <a:p>
             <a:pPr algn="ctr">
-              <a:defRPr sz="950" b="1">
+              <a:defRPr sz="1000" b="1">
                 <a:solidFill>
                   <a:srgbClr val="93C5FD"/>
                 </a:solidFill>
+                <a:latin typeface="Times New Roman"/>
               </a:defRPr>
             </a:pPr>
             <a:r>
@@ -4147,14 +4174,15 @@
           <a:lstStyle/>
           <a:p>
             <a:pPr>
-              <a:defRPr sz="2100" b="1">
-                <a:solidFill>
-                  <a:srgbClr val="F8FAFC"/>
-                </a:solidFill>
-              </a:defRPr>
-            </a:pPr>
-            <a:r>
-              <a:t>Five-Stage Enterprise Ingestion &amp; Audit Pipeline</a:t>
+              <a:defRPr sz="2200" b="1">
+                <a:solidFill>
+                  <a:srgbClr val="F8FAFC"/>
+                </a:solidFill>
+                <a:latin typeface="Times New Roman"/>
+              </a:defRPr>
+            </a:pPr>
+            <a:r>
+              <a:t>Five-Stage Enterprise Ingestion Pipeline &amp; Design Trade-Offs</a:t>
             </a:r>
           </a:p>
         </p:txBody>
@@ -4182,14 +4210,15 @@
           <a:lstStyle/>
           <a:p>
             <a:pPr algn="r">
-              <a:defRPr sz="1100" b="1">
+              <a:defRPr sz="1200" b="1">
                 <a:solidFill>
                   <a:srgbClr val="94A3B8"/>
                 </a:solidFill>
-              </a:defRPr>
-            </a:pPr>
-            <a:r>
-              <a:t>03/09</a:t>
+                <a:latin typeface="Times New Roman"/>
+              </a:defRPr>
+            </a:pPr>
+            <a:r>
+              <a:t>03/08</a:t>
             </a:r>
           </a:p>
         </p:txBody>
@@ -4265,10 +4294,11 @@
               <a:spcAft>
                 <a:spcPts val="800"/>
               </a:spcAft>
-              <a:defRPr sz="1400" b="1">
+              <a:defRPr sz="1500" b="1">
                 <a:solidFill>
                   <a:srgbClr val="38BDF8"/>
                 </a:solidFill>
+                <a:latin typeface="Times New Roman"/>
               </a:defRPr>
             </a:pPr>
             <a:r>
@@ -4280,85 +4310,75 @@
               <a:spcAft>
                 <a:spcPts val="500"/>
               </a:spcAft>
-              <a:defRPr sz="1150">
-                <a:solidFill>
-                  <a:srgbClr val="F8FAFC"/>
-                </a:solidFill>
-              </a:defRPr>
-            </a:pPr>
-            <a:r>
-              <a:t>• Stage 1: Validation Gatekeeper (document_validation_service.py)</a:t>
-            </a:r>
-          </a:p>
-          <a:p>
-            <a:pPr>
-              <a:spcAft>
-                <a:spcPts val="500"/>
-              </a:spcAft>
-              <a:defRPr sz="1150">
-                <a:solidFill>
-                  <a:srgbClr val="F8FAFC"/>
-                </a:solidFill>
-              </a:defRPr>
-            </a:pPr>
-            <a:r>
-              <a:t>•    • Magic byte file signature checks (%PDF, PNG, JPG). Rejects spoofed files.</a:t>
-            </a:r>
-          </a:p>
-          <a:p>
-            <a:pPr>
-              <a:spcAft>
-                <a:spcPts val="500"/>
-              </a:spcAft>
-              <a:defRPr sz="1150">
-                <a:solidFill>
-                  <a:srgbClr val="F8FAFC"/>
-                </a:solidFill>
-              </a:defRPr>
-            </a:pPr>
-            <a:r>
-              <a:t>•    • Enforces 25MB max size limit and file-type whitelist.</a:t>
-            </a:r>
-          </a:p>
-          <a:p>
-            <a:pPr>
-              <a:spcAft>
-                <a:spcPts val="500"/>
-              </a:spcAft>
-              <a:defRPr sz="1150">
-                <a:solidFill>
-                  <a:srgbClr val="F8FAFC"/>
-                </a:solidFill>
-              </a:defRPr>
-            </a:pPr>
-            <a:r>
-              <a:t>• Stage 2: Hybrid Dual-Engine OCR (ocr_service.py)</a:t>
-            </a:r>
-          </a:p>
-          <a:p>
-            <a:pPr>
-              <a:spcAft>
-                <a:spcPts val="500"/>
-              </a:spcAft>
-              <a:defRPr sz="1150">
-                <a:solidFill>
-                  <a:srgbClr val="F8FAFC"/>
-                </a:solidFill>
-              </a:defRPr>
-            </a:pPr>
-            <a:r>
-              <a:t>•    • Fast-Path: pypdfium2 native digital vector text stream parser (&lt;80ms).</a:t>
-            </a:r>
-          </a:p>
-          <a:p>
-            <a:pPr>
-              <a:spcAft>
-                <a:spcPts val="500"/>
-              </a:spcAft>
-              <a:defRPr sz="1150">
-                <a:solidFill>
-                  <a:srgbClr val="F8FAFC"/>
-                </a:solidFill>
+              <a:defRPr sz="1200">
+                <a:solidFill>
+                  <a:srgbClr val="F8FAFC"/>
+                </a:solidFill>
+                <a:latin typeface="Times New Roman"/>
+              </a:defRPr>
+            </a:pPr>
+            <a:r>
+              <a:t>• 1. Ingestion Gatekeeper (document_validation_service.py):</a:t>
+            </a:r>
+          </a:p>
+          <a:p>
+            <a:pPr>
+              <a:spcAft>
+                <a:spcPts val="500"/>
+              </a:spcAft>
+              <a:defRPr sz="1200">
+                <a:solidFill>
+                  <a:srgbClr val="F8FAFC"/>
+                </a:solidFill>
+                <a:latin typeface="Times New Roman"/>
+              </a:defRPr>
+            </a:pPr>
+            <a:r>
+              <a:t>•    • Magic byte signature verification (%PDF, PNG, JPG). Rejects spoofed files.</a:t>
+            </a:r>
+          </a:p>
+          <a:p>
+            <a:pPr>
+              <a:spcAft>
+                <a:spcPts val="500"/>
+              </a:spcAft>
+              <a:defRPr sz="1200">
+                <a:solidFill>
+                  <a:srgbClr val="F8FAFC"/>
+                </a:solidFill>
+                <a:latin typeface="Times New Roman"/>
+              </a:defRPr>
+            </a:pPr>
+            <a:r>
+              <a:t>• 2. Hybrid Dual-Engine OCR (ocr_service.py):</a:t>
+            </a:r>
+          </a:p>
+          <a:p>
+            <a:pPr>
+              <a:spcAft>
+                <a:spcPts val="500"/>
+              </a:spcAft>
+              <a:defRPr sz="1200">
+                <a:solidFill>
+                  <a:srgbClr val="F8FAFC"/>
+                </a:solidFill>
+                <a:latin typeface="Times New Roman"/>
+              </a:defRPr>
+            </a:pPr>
+            <a:r>
+              <a:t>•    • Fast-Path: pypdfium2 native digital vector stream parser (&lt;80ms).</a:t>
+            </a:r>
+          </a:p>
+          <a:p>
+            <a:pPr>
+              <a:spcAft>
+                <a:spcPts val="500"/>
+              </a:spcAft>
+              <a:defRPr sz="1200">
+                <a:solidFill>
+                  <a:srgbClr val="F8FAFC"/>
+                </a:solidFill>
+                <a:latin typeface="Times New Roman"/>
               </a:defRPr>
             </a:pPr>
             <a:r>
@@ -4370,89 +4390,95 @@
               <a:spcAft>
                 <a:spcPts val="500"/>
               </a:spcAft>
-              <a:defRPr sz="1150">
-                <a:solidFill>
-                  <a:srgbClr val="F8FAFC"/>
-                </a:solidFill>
-              </a:defRPr>
-            </a:pPr>
-            <a:r>
-              <a:t>• Stage 3: Token Reconstruction &amp; Table Parsing (table_extractor.py)</a:t>
-            </a:r>
-          </a:p>
-          <a:p>
-            <a:pPr>
-              <a:spcAft>
-                <a:spcPts val="500"/>
-              </a:spcAft>
-              <a:defRPr sz="1150">
-                <a:solidFill>
-                  <a:srgbClr val="F8FAFC"/>
-                </a:solidFill>
-              </a:defRPr>
-            </a:pPr>
-            <a:r>
-              <a:t>•    • Horizontal line clustering and multi-period column grid alignment.</a:t>
-            </a:r>
-          </a:p>
-          <a:p>
-            <a:pPr>
-              <a:spcAft>
-                <a:spcPts val="500"/>
-              </a:spcAft>
-              <a:defRPr sz="1150">
-                <a:solidFill>
-                  <a:srgbClr val="F8FAFC"/>
-                </a:solidFill>
-              </a:defRPr>
-            </a:pPr>
-            <a:r>
-              <a:t>• Stage 4: Deterministic Financial Audit (math_engine.py)</a:t>
-            </a:r>
-          </a:p>
-          <a:p>
-            <a:pPr>
-              <a:spcAft>
-                <a:spcPts val="500"/>
-              </a:spcAft>
-              <a:defRPr sz="1150">
-                <a:solidFill>
-                  <a:srgbClr val="F8FAFC"/>
-                </a:solidFill>
-              </a:defRPr>
-            </a:pPr>
-            <a:r>
-              <a:t>•    • Strict accounting equation verification; flags mathematical discrepancies.</a:t>
-            </a:r>
-          </a:p>
-          <a:p>
-            <a:pPr>
-              <a:spcAft>
-                <a:spcPts val="500"/>
-              </a:spcAft>
-              <a:defRPr sz="1150">
-                <a:solidFill>
-                  <a:srgbClr val="F8FAFC"/>
-                </a:solidFill>
-              </a:defRPr>
-            </a:pPr>
-            <a:r>
-              <a:t>• Stage 5: Persistence &amp; Interface (document_service.py)</a:t>
-            </a:r>
-          </a:p>
-          <a:p>
-            <a:pPr>
-              <a:spcAft>
-                <a:spcPts val="500"/>
-              </a:spcAft>
-              <a:defRPr sz="1150">
-                <a:solidFill>
-                  <a:srgbClr val="F8FAFC"/>
-                </a:solidFill>
-              </a:defRPr>
-            </a:pPr>
-            <a:r>
-              <a:t>•    • Relational storage via SQLAlchemy ORM; FastAPI REST router and Jinja2 UI.</a:t>
+              <a:defRPr sz="1200">
+                <a:solidFill>
+                  <a:srgbClr val="F8FAFC"/>
+                </a:solidFill>
+                <a:latin typeface="Times New Roman"/>
+              </a:defRPr>
+            </a:pPr>
+            <a:r>
+              <a:t>• 3. Layout Token Reconstruction (table_extractor.py):</a:t>
+            </a:r>
+          </a:p>
+          <a:p>
+            <a:pPr>
+              <a:spcAft>
+                <a:spcPts val="500"/>
+              </a:spcAft>
+              <a:defRPr sz="1200">
+                <a:solidFill>
+                  <a:srgbClr val="F8FAFC"/>
+                </a:solidFill>
+                <a:latin typeface="Times New Roman"/>
+              </a:defRPr>
+            </a:pPr>
+            <a:r>
+              <a:t>•    • Line clustering &amp; multi-column grid alignment.</a:t>
+            </a:r>
+          </a:p>
+          <a:p>
+            <a:pPr>
+              <a:spcAft>
+                <a:spcPts val="500"/>
+              </a:spcAft>
+              <a:defRPr sz="1200">
+                <a:solidFill>
+                  <a:srgbClr val="F8FAFC"/>
+                </a:solidFill>
+                <a:latin typeface="Times New Roman"/>
+              </a:defRPr>
+            </a:pPr>
+            <a:r>
+              <a:t>• 4. Deterministic Financial Audit (math_engine.py):</a:t>
+            </a:r>
+          </a:p>
+          <a:p>
+            <a:pPr>
+              <a:spcAft>
+                <a:spcPts val="500"/>
+              </a:spcAft>
+              <a:defRPr sz="1200">
+                <a:solidFill>
+                  <a:srgbClr val="F8FAFC"/>
+                </a:solidFill>
+                <a:latin typeface="Times New Roman"/>
+              </a:defRPr>
+            </a:pPr>
+            <a:r>
+              <a:t>•    • Strict accounting equation verification; catches line-item variances.</a:t>
+            </a:r>
+          </a:p>
+          <a:p>
+            <a:pPr>
+              <a:spcAft>
+                <a:spcPts val="500"/>
+              </a:spcAft>
+              <a:defRPr sz="1200">
+                <a:solidFill>
+                  <a:srgbClr val="F8FAFC"/>
+                </a:solidFill>
+                <a:latin typeface="Times New Roman"/>
+              </a:defRPr>
+            </a:pPr>
+            <a:r>
+              <a:t>• 5. Persistence &amp; Delivery (document_service.py):</a:t>
+            </a:r>
+          </a:p>
+          <a:p>
+            <a:pPr>
+              <a:spcAft>
+                <a:spcPts val="500"/>
+              </a:spcAft>
+              <a:defRPr sz="1200">
+                <a:solidFill>
+                  <a:srgbClr val="F8FAFC"/>
+                </a:solidFill>
+                <a:latin typeface="Times New Roman"/>
+              </a:defRPr>
+            </a:pPr>
+            <a:r>
+              <a:t>•    • SQLAlchemy 2.0 ORM, FastAPI REST router, and Jinja2 UI.</a:t>
             </a:r>
           </a:p>
         </p:txBody>
@@ -4528,25 +4554,27 @@
               <a:spcAft>
                 <a:spcPts val="800"/>
               </a:spcAft>
-              <a:defRPr sz="1400" b="1">
+              <a:defRPr sz="1500" b="1">
                 <a:solidFill>
                   <a:srgbClr val="34D399"/>
                 </a:solidFill>
-              </a:defRPr>
-            </a:pPr>
-            <a:r>
-              <a:t>Architectural Trade-Offs &amp; Senior Design Decisions  · [Trade-Offs]</a:t>
-            </a:r>
-          </a:p>
-          <a:p>
-            <a:pPr>
-              <a:spcAft>
-                <a:spcPts val="500"/>
-              </a:spcAft>
-              <a:defRPr sz="1150">
-                <a:solidFill>
-                  <a:srgbClr val="F8FAFC"/>
-                </a:solidFill>
+                <a:latin typeface="Times New Roman"/>
+              </a:defRPr>
+            </a:pPr>
+            <a:r>
+              <a:t>Senior Architectural Trade-Offs Made  · [Trade-Offs]</a:t>
+            </a:r>
+          </a:p>
+          <a:p>
+            <a:pPr>
+              <a:spcAft>
+                <a:spcPts val="500"/>
+              </a:spcAft>
+              <a:defRPr sz="1200">
+                <a:solidFill>
+                  <a:srgbClr val="F8FAFC"/>
+                </a:solidFill>
+                <a:latin typeface="Times New Roman"/>
               </a:defRPr>
             </a:pPr>
             <a:r>
@@ -4558,10 +4586,11 @@
               <a:spcAft>
                 <a:spcPts val="500"/>
               </a:spcAft>
-              <a:defRPr sz="1150">
-                <a:solidFill>
-                  <a:srgbClr val="F8FAFC"/>
-                </a:solidFill>
+              <a:defRPr sz="1200">
+                <a:solidFill>
+                  <a:srgbClr val="F8FAFC"/>
+                </a:solidFill>
+                <a:latin typeface="Times New Roman"/>
               </a:defRPr>
             </a:pPr>
             <a:r>
@@ -4573,10 +4602,11 @@
               <a:spcAft>
                 <a:spcPts val="500"/>
               </a:spcAft>
-              <a:defRPr sz="1150">
-                <a:solidFill>
-                  <a:srgbClr val="F8FAFC"/>
-                </a:solidFill>
+              <a:defRPr sz="1200">
+                <a:solidFill>
+                  <a:srgbClr val="F8FAFC"/>
+                </a:solidFill>
+                <a:latin typeface="Times New Roman"/>
               </a:defRPr>
             </a:pPr>
             <a:r>
@@ -4588,25 +4618,27 @@
               <a:spcAft>
                 <a:spcPts val="500"/>
               </a:spcAft>
-              <a:defRPr sz="1150">
-                <a:solidFill>
-                  <a:srgbClr val="F8FAFC"/>
-                </a:solidFill>
-              </a:defRPr>
-            </a:pPr>
-            <a:r>
-              <a:t>•    • Result: Docker image shrunk from 1.4GB to 380MB with zero DLL errors.</a:t>
-            </a:r>
-          </a:p>
-          <a:p>
-            <a:pPr>
-              <a:spcAft>
-                <a:spcPts val="500"/>
-              </a:spcAft>
-              <a:defRPr sz="1150">
-                <a:solidFill>
-                  <a:srgbClr val="F8FAFC"/>
-                </a:solidFill>
+              <a:defRPr sz="1200">
+                <a:solidFill>
+                  <a:srgbClr val="F8FAFC"/>
+                </a:solidFill>
+                <a:latin typeface="Times New Roman"/>
+              </a:defRPr>
+            </a:pPr>
+            <a:r>
+              <a:t>•    • Result: Shrunk Docker container from 1.4GB to 380MB with zero DLL errors.</a:t>
+            </a:r>
+          </a:p>
+          <a:p>
+            <a:pPr>
+              <a:spcAft>
+                <a:spcPts val="500"/>
+              </a:spcAft>
+              <a:defRPr sz="1200">
+                <a:solidFill>
+                  <a:srgbClr val="F8FAFC"/>
+                </a:solidFill>
+                <a:latin typeface="Times New Roman"/>
               </a:defRPr>
             </a:pPr>
             <a:r>
@@ -4618,40 +4650,43 @@
               <a:spcAft>
                 <a:spcPts val="500"/>
               </a:spcAft>
-              <a:defRPr sz="1150">
-                <a:solidFill>
-                  <a:srgbClr val="F8FAFC"/>
-                </a:solidFill>
-              </a:defRPr>
-            </a:pPr>
-            <a:r>
-              <a:t>• Trade-off: Deterministic Validation vs. LLM Summarization</a:t>
-            </a:r>
-          </a:p>
-          <a:p>
-            <a:pPr>
-              <a:spcAft>
-                <a:spcPts val="500"/>
-              </a:spcAft>
-              <a:defRPr sz="1150">
-                <a:solidFill>
-                  <a:srgbClr val="F8FAFC"/>
-                </a:solidFill>
-              </a:defRPr>
-            </a:pPr>
-            <a:r>
-              <a:t>•    • Decision: Pure Python accounting invariants engine.</a:t>
-            </a:r>
-          </a:p>
-          <a:p>
-            <a:pPr>
-              <a:spcAft>
-                <a:spcPts val="500"/>
-              </a:spcAft>
-              <a:defRPr sz="1150">
-                <a:solidFill>
-                  <a:srgbClr val="F8FAFC"/>
-                </a:solidFill>
+              <a:defRPr sz="1200">
+                <a:solidFill>
+                  <a:srgbClr val="F8FAFC"/>
+                </a:solidFill>
+                <a:latin typeface="Times New Roman"/>
+              </a:defRPr>
+            </a:pPr>
+            <a:r>
+              <a:t>• Trade-off: Deterministic Math vs. LLM Summaries</a:t>
+            </a:r>
+          </a:p>
+          <a:p>
+            <a:pPr>
+              <a:spcAft>
+                <a:spcPts val="500"/>
+              </a:spcAft>
+              <a:defRPr sz="1200">
+                <a:solidFill>
+                  <a:srgbClr val="F8FAFC"/>
+                </a:solidFill>
+                <a:latin typeface="Times New Roman"/>
+              </a:defRPr>
+            </a:pPr>
+            <a:r>
+              <a:t>•    • Decision: Pure Python accounting invariants engine with ±0.05 tolerance.</a:t>
+            </a:r>
+          </a:p>
+          <a:p>
+            <a:pPr>
+              <a:spcAft>
+                <a:spcPts val="500"/>
+              </a:spcAft>
+              <a:defRPr sz="1200">
+                <a:solidFill>
+                  <a:srgbClr val="F8FAFC"/>
+                </a:solidFill>
+                <a:latin typeface="Times New Roman"/>
               </a:defRPr>
             </a:pPr>
             <a:r>
@@ -4663,10 +4698,11 @@
               <a:spcAft>
                 <a:spcPts val="500"/>
               </a:spcAft>
-              <a:defRPr sz="1150">
-                <a:solidFill>
-                  <a:srgbClr val="F8FAFC"/>
-                </a:solidFill>
+              <a:defRPr sz="1200">
+                <a:solidFill>
+                  <a:srgbClr val="F8FAFC"/>
+                </a:solidFill>
+                <a:latin typeface="Times New Roman"/>
               </a:defRPr>
             </a:pPr>
             <a:r>
@@ -4678,44 +4714,47 @@
               <a:spcAft>
                 <a:spcPts val="500"/>
               </a:spcAft>
-              <a:defRPr sz="1150">
-                <a:solidFill>
-                  <a:srgbClr val="F8FAFC"/>
-                </a:solidFill>
-              </a:defRPr>
-            </a:pPr>
-            <a:r>
-              <a:t>• Trade-off: Monolith vs. Microservice</a:t>
-            </a:r>
-          </a:p>
-          <a:p>
-            <a:pPr>
-              <a:spcAft>
-                <a:spcPts val="500"/>
-              </a:spcAft>
-              <a:defRPr sz="1150">
-                <a:solidFill>
-                  <a:srgbClr val="F8FAFC"/>
-                </a:solidFill>
-              </a:defRPr>
-            </a:pPr>
-            <a:r>
-              <a:t>•    • Decision: Modular monolith (FastAPI + Jinja2 + SQLAlchemy).</a:t>
-            </a:r>
-          </a:p>
-          <a:p>
-            <a:pPr>
-              <a:spcAft>
-                <a:spcPts val="500"/>
-              </a:spcAft>
-              <a:defRPr sz="1150">
-                <a:solidFill>
-                  <a:srgbClr val="F8FAFC"/>
-                </a:solidFill>
-              </a:defRPr>
-            </a:pPr>
-            <a:r>
-              <a:t>•    • Impact: Zero network hops between UI and API; deployable as 1 Docker image.</a:t>
+              <a:defRPr sz="1200">
+                <a:solidFill>
+                  <a:srgbClr val="F8FAFC"/>
+                </a:solidFill>
+                <a:latin typeface="Times New Roman"/>
+              </a:defRPr>
+            </a:pPr>
+            <a:r>
+              <a:t>• Trade-off: Modular Monolith vs. Microservice</a:t>
+            </a:r>
+          </a:p>
+          <a:p>
+            <a:pPr>
+              <a:spcAft>
+                <a:spcPts val="500"/>
+              </a:spcAft>
+              <a:defRPr sz="1200">
+                <a:solidFill>
+                  <a:srgbClr val="F8FAFC"/>
+                </a:solidFill>
+                <a:latin typeface="Times New Roman"/>
+              </a:defRPr>
+            </a:pPr>
+            <a:r>
+              <a:t>•    • Decision: Single deployable Docker image with FastAPI + Jinja2.</a:t>
+            </a:r>
+          </a:p>
+          <a:p>
+            <a:pPr>
+              <a:spcAft>
+                <a:spcPts val="500"/>
+              </a:spcAft>
+              <a:defRPr sz="1200">
+                <a:solidFill>
+                  <a:srgbClr val="F8FAFC"/>
+                </a:solidFill>
+                <a:latin typeface="Times New Roman"/>
+              </a:defRPr>
+            </a:pPr>
+            <a:r>
+              <a:t>•    • Impact: Zero network hops between UI and backend; single-command deployment.</a:t>
             </a:r>
           </a:p>
         </p:txBody>
@@ -4753,7 +4792,7 @@
             <a:avLst/>
           </a:prstGeom>
           <a:solidFill>
-            <a:srgbClr val="0A0E17"/>
+            <a:srgbClr val="0B0F19"/>
           </a:solidFill>
           <a:ln>
             <a:noFill/>
@@ -4821,10 +4860,11 @@
           <a:lstStyle/>
           <a:p>
             <a:pPr algn="ctr">
-              <a:defRPr sz="950" b="1">
+              <a:defRPr sz="1000" b="1">
                 <a:solidFill>
                   <a:srgbClr val="93C5FD"/>
                 </a:solidFill>
+                <a:latin typeface="Times New Roman"/>
               </a:defRPr>
             </a:pPr>
             <a:r>
@@ -4856,14 +4896,15 @@
           <a:lstStyle/>
           <a:p>
             <a:pPr>
-              <a:defRPr sz="2100" b="1">
-                <a:solidFill>
-                  <a:srgbClr val="F8FAFC"/>
-                </a:solidFill>
-              </a:defRPr>
-            </a:pPr>
-            <a:r>
-              <a:t>Zero-Dependency OCR &amp; Low-Latency Text Extraction</a:t>
+              <a:defRPr sz="2200" b="1">
+                <a:solidFill>
+                  <a:srgbClr val="F8FAFC"/>
+                </a:solidFill>
+                <a:latin typeface="Times New Roman"/>
+              </a:defRPr>
+            </a:pPr>
+            <a:r>
+              <a:t>Zero-Dependency OCR &amp; Low-Latency Vision Architecture</a:t>
             </a:r>
           </a:p>
         </p:txBody>
@@ -4891,14 +4932,15 @@
           <a:lstStyle/>
           <a:p>
             <a:pPr algn="r">
-              <a:defRPr sz="1100" b="1">
+              <a:defRPr sz="1200" b="1">
                 <a:solidFill>
                   <a:srgbClr val="94A3B8"/>
                 </a:solidFill>
-              </a:defRPr>
-            </a:pPr>
-            <a:r>
-              <a:t>04/09</a:t>
+                <a:latin typeface="Times New Roman"/>
+              </a:defRPr>
+            </a:pPr>
+            <a:r>
+              <a:t>04/08</a:t>
             </a:r>
           </a:p>
         </p:txBody>
@@ -4974,55 +5016,59 @@
               <a:spcAft>
                 <a:spcPts val="800"/>
               </a:spcAft>
-              <a:defRPr sz="1400" b="1">
+              <a:defRPr sz="1500" b="1">
                 <a:solidFill>
                   <a:srgbClr val="38BDF8"/>
                 </a:solidFill>
-              </a:defRPr>
-            </a:pPr>
-            <a:r>
-              <a:t>Why Zero External Binary Dependencies Matters  · [Reliability]</a:t>
-            </a:r>
-          </a:p>
-          <a:p>
-            <a:pPr>
-              <a:spcAft>
-                <a:spcPts val="500"/>
-              </a:spcAft>
-              <a:defRPr sz="1150">
-                <a:solidFill>
-                  <a:srgbClr val="F8FAFC"/>
-                </a:solidFill>
-              </a:defRPr>
-            </a:pPr>
-            <a:r>
-              <a:t>• The Common Deployment Nightmare:</a:t>
-            </a:r>
-          </a:p>
-          <a:p>
-            <a:pPr>
-              <a:spcAft>
-                <a:spcPts val="500"/>
-              </a:spcAft>
-              <a:defRPr sz="1150">
-                <a:solidFill>
-                  <a:srgbClr val="F8FAFC"/>
-                </a:solidFill>
-              </a:defRPr>
-            </a:pPr>
-            <a:r>
-              <a:t>•    • 95% of candidates use pytesseract or pdf2image.</a:t>
-            </a:r>
-          </a:p>
-          <a:p>
-            <a:pPr>
-              <a:spcAft>
-                <a:spcPts val="500"/>
-              </a:spcAft>
-              <a:defRPr sz="1150">
-                <a:solidFill>
-                  <a:srgbClr val="F8FAFC"/>
-                </a:solidFill>
+                <a:latin typeface="Times New Roman"/>
+              </a:defRPr>
+            </a:pPr>
+            <a:r>
+              <a:t>Eliminating the C++ Binary Dependency Trap  · [Reliability]</a:t>
+            </a:r>
+          </a:p>
+          <a:p>
+            <a:pPr>
+              <a:spcAft>
+                <a:spcPts val="500"/>
+              </a:spcAft>
+              <a:defRPr sz="1200">
+                <a:solidFill>
+                  <a:srgbClr val="F8FAFC"/>
+                </a:solidFill>
+                <a:latin typeface="Times New Roman"/>
+              </a:defRPr>
+            </a:pPr>
+            <a:r>
+              <a:t>• The Common Deployment Vulnerability:</a:t>
+            </a:r>
+          </a:p>
+          <a:p>
+            <a:pPr>
+              <a:spcAft>
+                <a:spcPts val="500"/>
+              </a:spcAft>
+              <a:defRPr sz="1200">
+                <a:solidFill>
+                  <a:srgbClr val="F8FAFC"/>
+                </a:solidFill>
+                <a:latin typeface="Times New Roman"/>
+              </a:defRPr>
+            </a:pPr>
+            <a:r>
+              <a:t>•    • 95% of candidate projects rely on pytesseract and pdf2image.</a:t>
+            </a:r>
+          </a:p>
+          <a:p>
+            <a:pPr>
+              <a:spcAft>
+                <a:spcPts val="500"/>
+              </a:spcAft>
+              <a:defRPr sz="1200">
+                <a:solidFill>
+                  <a:srgbClr val="F8FAFC"/>
+                </a:solidFill>
+                <a:latin typeface="Times New Roman"/>
               </a:defRPr>
             </a:pPr>
             <a:r>
@@ -5034,25 +5080,27 @@
               <a:spcAft>
                 <a:spcPts val="500"/>
               </a:spcAft>
-              <a:defRPr sz="1150">
-                <a:solidFill>
-                  <a:srgbClr val="F8FAFC"/>
-                </a:solidFill>
-              </a:defRPr>
-            </a:pPr>
-            <a:r>
-              <a:t>•    • Results in broken PATHs, missing DLLs on Windows, and massive Docker bloat.</a:t>
-            </a:r>
-          </a:p>
-          <a:p>
-            <a:pPr>
-              <a:spcAft>
-                <a:spcPts val="500"/>
-              </a:spcAft>
-              <a:defRPr sz="1150">
-                <a:solidFill>
-                  <a:srgbClr val="F8FAFC"/>
-                </a:solidFill>
+              <a:defRPr sz="1200">
+                <a:solidFill>
+                  <a:srgbClr val="F8FAFC"/>
+                </a:solidFill>
+                <a:latin typeface="Times New Roman"/>
+              </a:defRPr>
+            </a:pPr>
+            <a:r>
+              <a:t>•    • Causes deployment failures on Windows/Render and 1GB+ container bloat.</a:t>
+            </a:r>
+          </a:p>
+          <a:p>
+            <a:pPr>
+              <a:spcAft>
+                <a:spcPts val="500"/>
+              </a:spcAft>
+              <a:defRPr sz="1200">
+                <a:solidFill>
+                  <a:srgbClr val="F8FAFC"/>
+                </a:solidFill>
+                <a:latin typeface="Times New Roman"/>
               </a:defRPr>
             </a:pPr>
             <a:r>
@@ -5064,10 +5112,11 @@
               <a:spcAft>
                 <a:spcPts val="500"/>
               </a:spcAft>
-              <a:defRPr sz="1150">
-                <a:solidFill>
-                  <a:srgbClr val="F8FAFC"/>
-                </a:solidFill>
+              <a:defRPr sz="1200">
+                <a:solidFill>
+                  <a:srgbClr val="F8FAFC"/>
+                </a:solidFill>
+                <a:latin typeface="Times New Roman"/>
               </a:defRPr>
             </a:pPr>
             <a:r>
@@ -5079,59 +5128,47 @@
               <a:spcAft>
                 <a:spcPts val="500"/>
               </a:spcAft>
-              <a:defRPr sz="1150">
-                <a:solidFill>
-                  <a:srgbClr val="F8FAFC"/>
-                </a:solidFill>
-              </a:defRPr>
-            </a:pPr>
-            <a:r>
-              <a:t>•    • pypdfium2: Bundles official Google PDFium engine inside Python wheels.</a:t>
-            </a:r>
-          </a:p>
-          <a:p>
-            <a:pPr>
-              <a:spcAft>
-                <a:spcPts val="500"/>
-              </a:spcAft>
-              <a:defRPr sz="1150">
-                <a:solidFill>
-                  <a:srgbClr val="F8FAFC"/>
-                </a:solidFill>
-              </a:defRPr>
-            </a:pPr>
-            <a:r>
-              <a:t>•    • RapidOCR: ONNX Runtime neural text detection and recognition.</a:t>
-            </a:r>
-          </a:p>
-          <a:p>
-            <a:pPr>
-              <a:spcAft>
-                <a:spcPts val="500"/>
-              </a:spcAft>
-              <a:defRPr sz="1150">
-                <a:solidFill>
-                  <a:srgbClr val="F8FAFC"/>
-                </a:solidFill>
-              </a:defRPr>
-            </a:pPr>
-            <a:r>
-              <a:t>•    • Zero Apt-Get Dependencies: Installs cleanly on standard Python 3.11.</a:t>
-            </a:r>
-          </a:p>
-          <a:p>
-            <a:pPr>
-              <a:spcAft>
-                <a:spcPts val="500"/>
-              </a:spcAft>
-              <a:defRPr sz="1150">
-                <a:solidFill>
-                  <a:srgbClr val="F8FAFC"/>
-                </a:solidFill>
-              </a:defRPr>
-            </a:pPr>
-            <a:r>
-              <a:t>•    • Portable: Runs identically on macOS, Windows, Linux, and cloud containers.</a:t>
+              <a:defRPr sz="1200">
+                <a:solidFill>
+                  <a:srgbClr val="F8FAFC"/>
+                </a:solidFill>
+                <a:latin typeface="Times New Roman"/>
+              </a:defRPr>
+            </a:pPr>
+            <a:r>
+              <a:t>•    • Bundles Google PDFium directly via pypdfium2 inside Python wheels.</a:t>
+            </a:r>
+          </a:p>
+          <a:p>
+            <a:pPr>
+              <a:spcAft>
+                <a:spcPts val="500"/>
+              </a:spcAft>
+              <a:defRPr sz="1200">
+                <a:solidFill>
+                  <a:srgbClr val="F8FAFC"/>
+                </a:solidFill>
+                <a:latin typeface="Times New Roman"/>
+              </a:defRPr>
+            </a:pPr>
+            <a:r>
+              <a:t>•    • Bundles ONNX Runtime CPU-quantized neural detection models.</a:t>
+            </a:r>
+          </a:p>
+          <a:p>
+            <a:pPr>
+              <a:spcAft>
+                <a:spcPts val="500"/>
+              </a:spcAft>
+              <a:defRPr sz="1200">
+                <a:solidFill>
+                  <a:srgbClr val="F8FAFC"/>
+                </a:solidFill>
+                <a:latin typeface="Times New Roman"/>
+              </a:defRPr>
+            </a:pPr>
+            <a:r>
+              <a:t>•    • Runs identically across Windows, Linux, and Docker without apt-get packages.</a:t>
             </a:r>
           </a:p>
         </p:txBody>
@@ -5207,85 +5244,91 @@
               <a:spcAft>
                 <a:spcPts val="800"/>
               </a:spcAft>
-              <a:defRPr sz="1400" b="1">
+              <a:defRPr sz="1500" b="1">
                 <a:solidFill>
                   <a:srgbClr val="34D399"/>
                 </a:solidFill>
-              </a:defRPr>
-            </a:pPr>
-            <a:r>
-              <a:t>Execution Performance &amp; Optimization  · [Performance]</a:t>
-            </a:r>
-          </a:p>
-          <a:p>
-            <a:pPr>
-              <a:spcAft>
-                <a:spcPts val="500"/>
-              </a:spcAft>
-              <a:defRPr sz="1150">
-                <a:solidFill>
-                  <a:srgbClr val="F8FAFC"/>
-                </a:solidFill>
-              </a:defRPr>
-            </a:pPr>
-            <a:r>
-              <a:t>• Dual-Mode Routing Strategy:</a:t>
-            </a:r>
-          </a:p>
-          <a:p>
-            <a:pPr>
-              <a:spcAft>
-                <a:spcPts val="500"/>
-              </a:spcAft>
-              <a:defRPr sz="1150">
-                <a:solidFill>
-                  <a:srgbClr val="F8FAFC"/>
-                </a:solidFill>
-              </a:defRPr>
-            </a:pPr>
-            <a:r>
-              <a:t>•    • Step 1: Detect native digital text layer via PDFium.</a:t>
-            </a:r>
-          </a:p>
-          <a:p>
-            <a:pPr>
-              <a:spcAft>
-                <a:spcPts val="500"/>
-              </a:spcAft>
-              <a:defRPr sz="1150">
-                <a:solidFill>
-                  <a:srgbClr val="F8FAFC"/>
-                </a:solidFill>
-              </a:defRPr>
-            </a:pPr>
-            <a:r>
-              <a:t>•    • If digital text density &gt; 90%: Parse in &lt;80 milliseconds with 100% precision.</a:t>
-            </a:r>
-          </a:p>
-          <a:p>
-            <a:pPr>
-              <a:spcAft>
-                <a:spcPts val="500"/>
-              </a:spcAft>
-              <a:defRPr sz="1150">
-                <a:solidFill>
-                  <a:srgbClr val="F8FAFC"/>
-                </a:solidFill>
-              </a:defRPr>
-            </a:pPr>
-            <a:r>
-              <a:t>•    • If scanned or image-based: Rasterize page at 200 DPI and run ONNX OCR.</a:t>
-            </a:r>
-          </a:p>
-          <a:p>
-            <a:pPr>
-              <a:spcAft>
-                <a:spcPts val="500"/>
-              </a:spcAft>
-              <a:defRPr sz="1150">
-                <a:solidFill>
-                  <a:srgbClr val="F8FAFC"/>
-                </a:solidFill>
+                <a:latin typeface="Times New Roman"/>
+              </a:defRPr>
+            </a:pPr>
+            <a:r>
+              <a:t>Dual-Mode Routing Strategy &amp; Latency Benchmarks  · [Performance]</a:t>
+            </a:r>
+          </a:p>
+          <a:p>
+            <a:pPr>
+              <a:spcAft>
+                <a:spcPts val="500"/>
+              </a:spcAft>
+              <a:defRPr sz="1200">
+                <a:solidFill>
+                  <a:srgbClr val="F8FAFC"/>
+                </a:solidFill>
+                <a:latin typeface="Times New Roman"/>
+              </a:defRPr>
+            </a:pPr>
+            <a:r>
+              <a:t>• Smart Execution Routing:</a:t>
+            </a:r>
+          </a:p>
+          <a:p>
+            <a:pPr>
+              <a:spcAft>
+                <a:spcPts val="500"/>
+              </a:spcAft>
+              <a:defRPr sz="1200">
+                <a:solidFill>
+                  <a:srgbClr val="F8FAFC"/>
+                </a:solidFill>
+                <a:latin typeface="Times New Roman"/>
+              </a:defRPr>
+            </a:pPr>
+            <a:r>
+              <a:t>•    • Step 1: Detect native digital text stream density via PDFium.</a:t>
+            </a:r>
+          </a:p>
+          <a:p>
+            <a:pPr>
+              <a:spcAft>
+                <a:spcPts val="500"/>
+              </a:spcAft>
+              <a:defRPr sz="1200">
+                <a:solidFill>
+                  <a:srgbClr val="F8FAFC"/>
+                </a:solidFill>
+                <a:latin typeface="Times New Roman"/>
+              </a:defRPr>
+            </a:pPr>
+            <a:r>
+              <a:t>•    • Digital Text &gt; 90%: Parsed in &lt;80 milliseconds with 100% character fidelity.</a:t>
+            </a:r>
+          </a:p>
+          <a:p>
+            <a:pPr>
+              <a:spcAft>
+                <a:spcPts val="500"/>
+              </a:spcAft>
+              <a:defRPr sz="1200">
+                <a:solidFill>
+                  <a:srgbClr val="F8FAFC"/>
+                </a:solidFill>
+                <a:latin typeface="Times New Roman"/>
+              </a:defRPr>
+            </a:pPr>
+            <a:r>
+              <a:t>•    • Scanned or Noisy Images: Rasterized at 200 DPI and processed via ONNX OCR.</a:t>
+            </a:r>
+          </a:p>
+          <a:p>
+            <a:pPr>
+              <a:spcAft>
+                <a:spcPts val="500"/>
+              </a:spcAft>
+              <a:defRPr sz="1200">
+                <a:solidFill>
+                  <a:srgbClr val="F8FAFC"/>
+                </a:solidFill>
+                <a:latin typeface="Times New Roman"/>
               </a:defRPr>
             </a:pPr>
             <a:r>
@@ -5297,74 +5340,47 @@
               <a:spcAft>
                 <a:spcPts val="500"/>
               </a:spcAft>
-              <a:defRPr sz="1150">
-                <a:solidFill>
-                  <a:srgbClr val="F8FAFC"/>
-                </a:solidFill>
-              </a:defRPr>
-            </a:pPr>
-            <a:r>
-              <a:t>• Inference Speed Benchmarks:</a:t>
-            </a:r>
-          </a:p>
-          <a:p>
-            <a:pPr>
-              <a:spcAft>
-                <a:spcPts val="500"/>
-              </a:spcAft>
-              <a:defRPr sz="1150">
-                <a:solidFill>
-                  <a:srgbClr val="F8FAFC"/>
-                </a:solidFill>
-              </a:defRPr>
-            </a:pPr>
-            <a:r>
-              <a:t>•    • Average digital PDF processing latency: 120ms per document.</a:t>
-            </a:r>
-          </a:p>
-          <a:p>
-            <a:pPr>
-              <a:spcAft>
-                <a:spcPts val="500"/>
-              </a:spcAft>
-              <a:defRPr sz="1150">
-                <a:solidFill>
-                  <a:srgbClr val="F8FAFC"/>
-                </a:solidFill>
-              </a:defRPr>
-            </a:pPr>
-            <a:r>
-              <a:t>•    • Average scanned OCR processing latency: 680ms per document.</a:t>
-            </a:r>
-          </a:p>
-          <a:p>
-            <a:pPr>
-              <a:spcAft>
-                <a:spcPts val="500"/>
-              </a:spcAft>
-              <a:defRPr sz="1150">
-                <a:solidFill>
-                  <a:srgbClr val="F8FAFC"/>
-                </a:solidFill>
-              </a:defRPr>
-            </a:pPr>
-            <a:r>
-              <a:t>•    • 10x faster than cloud vision APIs (AWS Textract, Google Document AI).</a:t>
-            </a:r>
-          </a:p>
-          <a:p>
-            <a:pPr>
-              <a:spcAft>
-                <a:spcPts val="500"/>
-              </a:spcAft>
-              <a:defRPr sz="1150">
-                <a:solidFill>
-                  <a:srgbClr val="F8FAFC"/>
-                </a:solidFill>
-              </a:defRPr>
-            </a:pPr>
-            <a:r>
-              <a:t>•    • Fully functional on standard 1-vCPU free-tier cloud containers.</a:t>
+              <a:defRPr sz="1200">
+                <a:solidFill>
+                  <a:srgbClr val="F8FAFC"/>
+                </a:solidFill>
+                <a:latin typeface="Times New Roman"/>
+              </a:defRPr>
+            </a:pPr>
+            <a:r>
+              <a:t>• Latency Benchmarks:</a:t>
+            </a:r>
+          </a:p>
+          <a:p>
+            <a:pPr>
+              <a:spcAft>
+                <a:spcPts val="500"/>
+              </a:spcAft>
+              <a:defRPr sz="1200">
+                <a:solidFill>
+                  <a:srgbClr val="F8FAFC"/>
+                </a:solidFill>
+                <a:latin typeface="Times New Roman"/>
+              </a:defRPr>
+            </a:pPr>
+            <a:r>
+              <a:t>•    • Digital PDFs: ~120ms | Scanned OCR: ~680ms.</a:t>
+            </a:r>
+          </a:p>
+          <a:p>
+            <a:pPr>
+              <a:spcAft>
+                <a:spcPts val="500"/>
+              </a:spcAft>
+              <a:defRPr sz="1200">
+                <a:solidFill>
+                  <a:srgbClr val="F8FAFC"/>
+                </a:solidFill>
+                <a:latin typeface="Times New Roman"/>
+              </a:defRPr>
+            </a:pPr>
+            <a:r>
+              <a:t>•    • 10x faster than cloud vision APIs on standard 1-CPU cloud instances.</a:t>
             </a:r>
           </a:p>
         </p:txBody>
@@ -5402,7 +5418,7 @@
             <a:avLst/>
           </a:prstGeom>
           <a:solidFill>
-            <a:srgbClr val="0A0E17"/>
+            <a:srgbClr val="0B0F19"/>
           </a:solidFill>
           <a:ln>
             <a:noFill/>
@@ -5470,10 +5486,11 @@
           <a:lstStyle/>
           <a:p>
             <a:pPr algn="ctr">
-              <a:defRPr sz="950" b="1">
+              <a:defRPr sz="1000" b="1">
                 <a:solidFill>
                   <a:srgbClr val="93C5FD"/>
                 </a:solidFill>
+                <a:latin typeface="Times New Roman"/>
               </a:defRPr>
             </a:pPr>
             <a:r>
@@ -5505,10 +5522,11 @@
           <a:lstStyle/>
           <a:p>
             <a:pPr>
-              <a:defRPr sz="2100" b="1">
-                <a:solidFill>
-                  <a:srgbClr val="F8FAFC"/>
-                </a:solidFill>
+              <a:defRPr sz="2200" b="1">
+                <a:solidFill>
+                  <a:srgbClr val="F8FAFC"/>
+                </a:solidFill>
+                <a:latin typeface="Times New Roman"/>
               </a:defRPr>
             </a:pPr>
             <a:r>
@@ -5540,14 +5558,15 @@
           <a:lstStyle/>
           <a:p>
             <a:pPr algn="r">
-              <a:defRPr sz="1100" b="1">
+              <a:defRPr sz="1200" b="1">
                 <a:solidFill>
                   <a:srgbClr val="94A3B8"/>
                 </a:solidFill>
-              </a:defRPr>
-            </a:pPr>
-            <a:r>
-              <a:t>05/09</a:t>
+                <a:latin typeface="Times New Roman"/>
+              </a:defRPr>
+            </a:pPr>
+            <a:r>
+              <a:t>05/08</a:t>
             </a:r>
           </a:p>
         </p:txBody>
@@ -5623,25 +5642,27 @@
               <a:spcAft>
                 <a:spcPts val="800"/>
               </a:spcAft>
-              <a:defRPr sz="1400" b="1">
+              <a:defRPr sz="1500" b="1">
                 <a:solidFill>
                   <a:srgbClr val="38BDF8"/>
                 </a:solidFill>
-              </a:defRPr>
-            </a:pPr>
-            <a:r>
-              <a:t>Accounting Identities Enforced Across 4 Categories  · [Accounting Rules]</a:t>
-            </a:r>
-          </a:p>
-          <a:p>
-            <a:pPr>
-              <a:spcAft>
-                <a:spcPts val="500"/>
-              </a:spcAft>
-              <a:defRPr sz="1150">
-                <a:solidFill>
-                  <a:srgbClr val="F8FAFC"/>
-                </a:solidFill>
+                <a:latin typeface="Times New Roman"/>
+              </a:defRPr>
+            </a:pPr>
+            <a:r>
+              <a:t>Accounting Identities Enforced Across 4 Categories  · [Formulas]</a:t>
+            </a:r>
+          </a:p>
+          <a:p>
+            <a:pPr>
+              <a:spcAft>
+                <a:spcPts val="500"/>
+              </a:spcAft>
+              <a:defRPr sz="1200">
+                <a:solidFill>
+                  <a:srgbClr val="F8FAFC"/>
+                </a:solidFill>
+                <a:latin typeface="Times New Roman"/>
               </a:defRPr>
             </a:pPr>
             <a:r>
@@ -5653,10 +5674,11 @@
               <a:spcAft>
                 <a:spcPts val="500"/>
               </a:spcAft>
-              <a:defRPr sz="1150">
-                <a:solidFill>
-                  <a:srgbClr val="F8FAFC"/>
-                </a:solidFill>
+              <a:defRPr sz="1200">
+                <a:solidFill>
+                  <a:srgbClr val="F8FAFC"/>
+                </a:solidFill>
+                <a:latin typeface="Times New Roman"/>
               </a:defRPr>
             </a:pPr>
             <a:r>
@@ -5668,10 +5690,11 @@
               <a:spcAft>
                 <a:spcPts val="500"/>
               </a:spcAft>
-              <a:defRPr sz="1150">
-                <a:solidFill>
-                  <a:srgbClr val="F8FAFC"/>
-                </a:solidFill>
+              <a:defRPr sz="1200">
+                <a:solidFill>
+                  <a:srgbClr val="F8FAFC"/>
+                </a:solidFill>
+                <a:latin typeface="Times New Roman"/>
               </a:defRPr>
             </a:pPr>
             <a:r>
@@ -5683,10 +5706,11 @@
               <a:spcAft>
                 <a:spcPts val="500"/>
               </a:spcAft>
-              <a:defRPr sz="1150">
-                <a:solidFill>
-                  <a:srgbClr val="F8FAFC"/>
-                </a:solidFill>
+              <a:defRPr sz="1200">
+                <a:solidFill>
+                  <a:srgbClr val="F8FAFC"/>
+                </a:solidFill>
+                <a:latin typeface="Times New Roman"/>
               </a:defRPr>
             </a:pPr>
             <a:r>
@@ -5698,10 +5722,11 @@
               <a:spcAft>
                 <a:spcPts val="500"/>
               </a:spcAft>
-              <a:defRPr sz="1150">
-                <a:solidFill>
-                  <a:srgbClr val="F8FAFC"/>
-                </a:solidFill>
+              <a:defRPr sz="1200">
+                <a:solidFill>
+                  <a:srgbClr val="F8FAFC"/>
+                </a:solidFill>
+                <a:latin typeface="Times New Roman"/>
               </a:defRPr>
             </a:pPr>
             <a:r>
@@ -5713,10 +5738,11 @@
               <a:spcAft>
                 <a:spcPts val="500"/>
               </a:spcAft>
-              <a:defRPr sz="1150">
-                <a:solidFill>
-                  <a:srgbClr val="F8FAFC"/>
-                </a:solidFill>
+              <a:defRPr sz="1200">
+                <a:solidFill>
+                  <a:srgbClr val="F8FAFC"/>
+                </a:solidFill>
+                <a:latin typeface="Times New Roman"/>
               </a:defRPr>
             </a:pPr>
             <a:r>
@@ -5728,25 +5754,27 @@
               <a:spcAft>
                 <a:spcPts val="500"/>
               </a:spcAft>
-              <a:defRPr sz="1150">
-                <a:solidFill>
-                  <a:srgbClr val="F8FAFC"/>
-                </a:solidFill>
-              </a:defRPr>
-            </a:pPr>
-            <a:r>
-              <a:t>•    • Total Reconciliation: Total Amount == Subtotal + Tax - Discount</a:t>
-            </a:r>
-          </a:p>
-          <a:p>
-            <a:pPr>
-              <a:spcAft>
-                <a:spcPts val="500"/>
-              </a:spcAft>
-              <a:defRPr sz="1150">
-                <a:solidFill>
-                  <a:srgbClr val="F8FAFC"/>
-                </a:solidFill>
+              <a:defRPr sz="1200">
+                <a:solidFill>
+                  <a:srgbClr val="F8FAFC"/>
+                </a:solidFill>
+                <a:latin typeface="Times New Roman"/>
+              </a:defRPr>
+            </a:pPr>
+            <a:r>
+              <a:t>•    • Total Reconciliation: Total Amount == Subtotal + Tax - Discounts</a:t>
+            </a:r>
+          </a:p>
+          <a:p>
+            <a:pPr>
+              <a:spcAft>
+                <a:spcPts val="500"/>
+              </a:spcAft>
+              <a:defRPr sz="1200">
+                <a:solidFill>
+                  <a:srgbClr val="F8FAFC"/>
+                </a:solidFill>
+                <a:latin typeface="Times New Roman"/>
               </a:defRPr>
             </a:pPr>
             <a:r>
@@ -5758,10 +5786,11 @@
               <a:spcAft>
                 <a:spcPts val="500"/>
               </a:spcAft>
-              <a:defRPr sz="1150">
-                <a:solidFill>
-                  <a:srgbClr val="F8FAFC"/>
-                </a:solidFill>
+              <a:defRPr sz="1200">
+                <a:solidFill>
+                  <a:srgbClr val="F8FAFC"/>
+                </a:solidFill>
+                <a:latin typeface="Times New Roman"/>
               </a:defRPr>
             </a:pPr>
             <a:r>
@@ -5773,10 +5802,11 @@
               <a:spcAft>
                 <a:spcPts val="500"/>
               </a:spcAft>
-              <a:defRPr sz="1150">
-                <a:solidFill>
-                  <a:srgbClr val="F8FAFC"/>
-                </a:solidFill>
+              <a:defRPr sz="1200">
+                <a:solidFill>
+                  <a:srgbClr val="F8FAFC"/>
+                </a:solidFill>
+                <a:latin typeface="Times New Roman"/>
               </a:defRPr>
             </a:pPr>
             <a:r>
@@ -5788,10 +5818,11 @@
               <a:spcAft>
                 <a:spcPts val="500"/>
               </a:spcAft>
-              <a:defRPr sz="1150">
-                <a:solidFill>
-                  <a:srgbClr val="F8FAFC"/>
-                </a:solidFill>
+              <a:defRPr sz="1200">
+                <a:solidFill>
+                  <a:srgbClr val="F8FAFC"/>
+                </a:solidFill>
+                <a:latin typeface="Times New Roman"/>
               </a:defRPr>
             </a:pPr>
             <a:r>
@@ -5803,10 +5834,11 @@
               <a:spcAft>
                 <a:spcPts val="500"/>
               </a:spcAft>
-              <a:defRPr sz="1150">
-                <a:solidFill>
-                  <a:srgbClr val="F8FAFC"/>
-                </a:solidFill>
+              <a:defRPr sz="1200">
+                <a:solidFill>
+                  <a:srgbClr val="F8FAFC"/>
+                </a:solidFill>
+                <a:latin typeface="Times New Roman"/>
               </a:defRPr>
             </a:pPr>
             <a:r>
@@ -5818,10 +5850,11 @@
               <a:spcAft>
                 <a:spcPts val="500"/>
               </a:spcAft>
-              <a:defRPr sz="1150">
-                <a:solidFill>
-                  <a:srgbClr val="F8FAFC"/>
-                </a:solidFill>
+              <a:defRPr sz="1200">
+                <a:solidFill>
+                  <a:srgbClr val="F8FAFC"/>
+                </a:solidFill>
+                <a:latin typeface="Times New Roman"/>
               </a:defRPr>
             </a:pPr>
             <a:r>
@@ -5833,10 +5866,11 @@
               <a:spcAft>
                 <a:spcPts val="500"/>
               </a:spcAft>
-              <a:defRPr sz="1150">
-                <a:solidFill>
-                  <a:srgbClr val="F8FAFC"/>
-                </a:solidFill>
+              <a:defRPr sz="1200">
+                <a:solidFill>
+                  <a:srgbClr val="F8FAFC"/>
+                </a:solidFill>
+                <a:latin typeface="Times New Roman"/>
               </a:defRPr>
             </a:pPr>
             <a:r>
@@ -5916,70 +5950,75 @@
               <a:spcAft>
                 <a:spcPts val="800"/>
               </a:spcAft>
-              <a:defRPr sz="1400" b="1">
+              <a:defRPr sz="1500" b="1">
                 <a:solidFill>
                   <a:srgbClr val="34D399"/>
                 </a:solidFill>
-              </a:defRPr>
-            </a:pPr>
-            <a:r>
-              <a:t>Floating-Point Delta Tolerance &amp; Fraud Detection  · [Audit Engine]</a:t>
-            </a:r>
-          </a:p>
-          <a:p>
-            <a:pPr>
-              <a:spcAft>
-                <a:spcPts val="500"/>
-              </a:spcAft>
-              <a:defRPr sz="1150">
-                <a:solidFill>
-                  <a:srgbClr val="F8FAFC"/>
-                </a:solidFill>
-              </a:defRPr>
-            </a:pPr>
-            <a:r>
-              <a:t>• Handling Floating-Point Precision Drift:</a:t>
-            </a:r>
-          </a:p>
-          <a:p>
-            <a:pPr>
-              <a:spcAft>
-                <a:spcPts val="500"/>
-              </a:spcAft>
-              <a:defRPr sz="1150">
-                <a:solidFill>
-                  <a:srgbClr val="F8FAFC"/>
-                </a:solidFill>
-              </a:defRPr>
-            </a:pPr>
-            <a:r>
-              <a:t>•    • Real financial records have legal round-off cent deltas ($0.01 - $0.03).</a:t>
-            </a:r>
-          </a:p>
-          <a:p>
-            <a:pPr>
-              <a:spcAft>
-                <a:spcPts val="500"/>
-              </a:spcAft>
-              <a:defRPr sz="1150">
-                <a:solidFill>
-                  <a:srgbClr val="F8FAFC"/>
-                </a:solidFill>
-              </a:defRPr>
-            </a:pPr>
-            <a:r>
-              <a:t>•    • Enforces strict mathematical tolerance: abs(calculated - stated) &lt;= 0.05.</a:t>
-            </a:r>
-          </a:p>
-          <a:p>
-            <a:pPr>
-              <a:spcAft>
-                <a:spcPts val="500"/>
-              </a:spcAft>
-              <a:defRPr sz="1150">
-                <a:solidFill>
-                  <a:srgbClr val="F8FAFC"/>
-                </a:solidFill>
+                <a:latin typeface="Times New Roman"/>
+              </a:defRPr>
+            </a:pPr>
+            <a:r>
+              <a:t>Floating-Point Delta Tolerance &amp; Discrepancy Logic  · [Audit Engine]</a:t>
+            </a:r>
+          </a:p>
+          <a:p>
+            <a:pPr>
+              <a:spcAft>
+                <a:spcPts val="500"/>
+              </a:spcAft>
+              <a:defRPr sz="1200">
+                <a:solidFill>
+                  <a:srgbClr val="F8FAFC"/>
+                </a:solidFill>
+                <a:latin typeface="Times New Roman"/>
+              </a:defRPr>
+            </a:pPr>
+            <a:r>
+              <a:t>• Precision Drift Defense:</a:t>
+            </a:r>
+          </a:p>
+          <a:p>
+            <a:pPr>
+              <a:spcAft>
+                <a:spcPts val="500"/>
+              </a:spcAft>
+              <a:defRPr sz="1200">
+                <a:solidFill>
+                  <a:srgbClr val="F8FAFC"/>
+                </a:solidFill>
+                <a:latin typeface="Times New Roman"/>
+              </a:defRPr>
+            </a:pPr>
+            <a:r>
+              <a:t>•    • Real records contain legal round-off cent deltas ($0.01 - $0.03).</a:t>
+            </a:r>
+          </a:p>
+          <a:p>
+            <a:pPr>
+              <a:spcAft>
+                <a:spcPts val="500"/>
+              </a:spcAft>
+              <a:defRPr sz="1200">
+                <a:solidFill>
+                  <a:srgbClr val="F8FAFC"/>
+                </a:solidFill>
+                <a:latin typeface="Times New Roman"/>
+              </a:defRPr>
+            </a:pPr>
+            <a:r>
+              <a:t>•    • Implemented tolerance delta: abs(calculated - stated) &lt;= 0.05.</a:t>
+            </a:r>
+          </a:p>
+          <a:p>
+            <a:pPr>
+              <a:spcAft>
+                <a:spcPts val="500"/>
+              </a:spcAft>
+              <a:defRPr sz="1200">
+                <a:solidFill>
+                  <a:srgbClr val="F8FAFC"/>
+                </a:solidFill>
+                <a:latin typeface="Times New Roman"/>
               </a:defRPr>
             </a:pPr>
             <a:r>
@@ -5991,70 +6030,75 @@
               <a:spcAft>
                 <a:spcPts val="500"/>
               </a:spcAft>
-              <a:defRPr sz="1150">
-                <a:solidFill>
-                  <a:srgbClr val="F8FAFC"/>
-                </a:solidFill>
-              </a:defRPr>
-            </a:pPr>
-            <a:r>
-              <a:t>• Discrepancy &amp; Anomaly Detection in Practice:</a:t>
-            </a:r>
-          </a:p>
-          <a:p>
-            <a:pPr>
-              <a:spcAft>
-                <a:spcPts val="500"/>
-              </a:spcAft>
-              <a:defRPr sz="1150">
-                <a:solidFill>
-                  <a:srgbClr val="F8FAFC"/>
-                </a:solidFill>
-              </a:defRPr>
-            </a:pPr>
-            <a:r>
-              <a:t>•    • If variance &gt; 0.05: The invariant is marked FAILED.</a:t>
-            </a:r>
-          </a:p>
-          <a:p>
-            <a:pPr>
-              <a:spcAft>
-                <a:spcPts val="500"/>
-              </a:spcAft>
-              <a:defRPr sz="1150">
-                <a:solidFill>
-                  <a:srgbClr val="F8FAFC"/>
-                </a:solidFill>
-              </a:defRPr>
-            </a:pPr>
-            <a:r>
-              <a:t>•    • The UI renders a high-visibility Red Discrepancy Card showing the exact numerical difference.</a:t>
-            </a:r>
-          </a:p>
-          <a:p>
-            <a:pPr>
-              <a:spcAft>
-                <a:spcPts val="500"/>
-              </a:spcAft>
-              <a:defRPr sz="1150">
-                <a:solidFill>
-                  <a:srgbClr val="F8FAFC"/>
-                </a:solidFill>
-              </a:defRPr>
-            </a:pPr>
-            <a:r>
-              <a:t>•    • Real finding from dataset: Caught a Cash Flow statement where financing outflow was mistakenly listed as an inflow in the summary.</a:t>
-            </a:r>
-          </a:p>
-          <a:p>
-            <a:pPr>
-              <a:spcAft>
-                <a:spcPts val="500"/>
-              </a:spcAft>
-              <a:defRPr sz="1150">
-                <a:solidFill>
-                  <a:srgbClr val="F8FAFC"/>
-                </a:solidFill>
+              <a:defRPr sz="1200">
+                <a:solidFill>
+                  <a:srgbClr val="F8FAFC"/>
+                </a:solidFill>
+                <a:latin typeface="Times New Roman"/>
+              </a:defRPr>
+            </a:pPr>
+            <a:r>
+              <a:t>• Discrepancy Catching:</a:t>
+            </a:r>
+          </a:p>
+          <a:p>
+            <a:pPr>
+              <a:spcAft>
+                <a:spcPts val="500"/>
+              </a:spcAft>
+              <a:defRPr sz="1200">
+                <a:solidFill>
+                  <a:srgbClr val="F8FAFC"/>
+                </a:solidFill>
+                <a:latin typeface="Times New Roman"/>
+              </a:defRPr>
+            </a:pPr>
+            <a:r>
+              <a:t>•    • If delta &gt; 0.05: The invariant status is marked FAILED.</a:t>
+            </a:r>
+          </a:p>
+          <a:p>
+            <a:pPr>
+              <a:spcAft>
+                <a:spcPts val="500"/>
+              </a:spcAft>
+              <a:defRPr sz="1200">
+                <a:solidFill>
+                  <a:srgbClr val="F8FAFC"/>
+                </a:solidFill>
+                <a:latin typeface="Times New Roman"/>
+              </a:defRPr>
+            </a:pPr>
+            <a:r>
+              <a:t>•    • Renders a high-visibility Red Audit Card with exact variance calculated.</a:t>
+            </a:r>
+          </a:p>
+          <a:p>
+            <a:pPr>
+              <a:spcAft>
+                <a:spcPts val="500"/>
+              </a:spcAft>
+              <a:defRPr sz="1200">
+                <a:solidFill>
+                  <a:srgbClr val="F8FAFC"/>
+                </a:solidFill>
+                <a:latin typeface="Times New Roman"/>
+              </a:defRPr>
+            </a:pPr>
+            <a:r>
+              <a:t>•    • Real Finding: Flagged a real-world Cash Flow document where financing outflow was miscategorized as an inflow in the summary.</a:t>
+            </a:r>
+          </a:p>
+          <a:p>
+            <a:pPr>
+              <a:spcAft>
+                <a:spcPts val="500"/>
+              </a:spcAft>
+              <a:defRPr sz="1200">
+                <a:solidFill>
+                  <a:srgbClr val="F8FAFC"/>
+                </a:solidFill>
+                <a:latin typeface="Times New Roman"/>
               </a:defRPr>
             </a:pPr>
             <a:r>
@@ -6096,7 +6140,7 @@
             <a:avLst/>
           </a:prstGeom>
           <a:solidFill>
-            <a:srgbClr val="0A0E17"/>
+            <a:srgbClr val="0B0F19"/>
           </a:solidFill>
           <a:ln>
             <a:noFill/>
@@ -6164,10 +6208,11 @@
           <a:lstStyle/>
           <a:p>
             <a:pPr algn="ctr">
-              <a:defRPr sz="950" b="1">
+              <a:defRPr sz="1000" b="1">
                 <a:solidFill>
                   <a:srgbClr val="93C5FD"/>
                 </a:solidFill>
+                <a:latin typeface="Times New Roman"/>
               </a:defRPr>
             </a:pPr>
             <a:r>
@@ -6199,10 +6244,11 @@
           <a:lstStyle/>
           <a:p>
             <a:pPr>
-              <a:defRPr sz="2100" b="1">
-                <a:solidFill>
-                  <a:srgbClr val="F8FAFC"/>
-                </a:solidFill>
+              <a:defRPr sz="2200" b="1">
+                <a:solidFill>
+                  <a:srgbClr val="F8FAFC"/>
+                </a:solidFill>
+                <a:latin typeface="Times New Roman"/>
               </a:defRPr>
             </a:pPr>
             <a:r>
@@ -6234,14 +6280,15 @@
           <a:lstStyle/>
           <a:p>
             <a:pPr algn="r">
-              <a:defRPr sz="1100" b="1">
+              <a:defRPr sz="1200" b="1">
                 <a:solidFill>
                   <a:srgbClr val="94A3B8"/>
                 </a:solidFill>
-              </a:defRPr>
-            </a:pPr>
-            <a:r>
-              <a:t>06/09</a:t>
+                <a:latin typeface="Times New Roman"/>
+              </a:defRPr>
+            </a:pPr>
+            <a:r>
+              <a:t>06/08</a:t>
             </a:r>
           </a:p>
         </p:txBody>
@@ -6317,10 +6364,11 @@
               <a:spcAft>
                 <a:spcPts val="800"/>
               </a:spcAft>
-              <a:defRPr sz="1400" b="1">
+              <a:defRPr sz="1500" b="1">
                 <a:solidFill>
                   <a:srgbClr val="38BDF8"/>
                 </a:solidFill>
+                <a:latin typeface="Times New Roman"/>
               </a:defRPr>
             </a:pPr>
             <a:r>
@@ -6332,40 +6380,43 @@
               <a:spcAft>
                 <a:spcPts val="500"/>
               </a:spcAft>
-              <a:defRPr sz="1150">
-                <a:solidFill>
-                  <a:srgbClr val="F8FAFC"/>
-                </a:solidFill>
-              </a:defRPr>
-            </a:pPr>
-            <a:r>
-              <a:t>• Why Provenance Citations are Mandatory:</a:t>
-            </a:r>
-          </a:p>
-          <a:p>
-            <a:pPr>
-              <a:spcAft>
-                <a:spcPts val="500"/>
-              </a:spcAft>
-              <a:defRPr sz="1150">
-                <a:solidFill>
-                  <a:srgbClr val="F8FAFC"/>
-                </a:solidFill>
-              </a:defRPr>
-            </a:pPr>
-            <a:r>
-              <a:t>•    • In SOX, IFRS, and GAAP audits, unverified AI outputs are illegal.</a:t>
-            </a:r>
-          </a:p>
-          <a:p>
-            <a:pPr>
-              <a:spcAft>
-                <a:spcPts val="500"/>
-              </a:spcAft>
-              <a:defRPr sz="1150">
-                <a:solidFill>
-                  <a:srgbClr val="F8FAFC"/>
-                </a:solidFill>
+              <a:defRPr sz="1200">
+                <a:solidFill>
+                  <a:srgbClr val="F8FAFC"/>
+                </a:solidFill>
+                <a:latin typeface="Times New Roman"/>
+              </a:defRPr>
+            </a:pPr>
+            <a:r>
+              <a:t>• Why Provenance Citations are Mandatory for SOX/IFRS:</a:t>
+            </a:r>
+          </a:p>
+          <a:p>
+            <a:pPr>
+              <a:spcAft>
+                <a:spcPts val="500"/>
+              </a:spcAft>
+              <a:defRPr sz="1200">
+                <a:solidFill>
+                  <a:srgbClr val="F8FAFC"/>
+                </a:solidFill>
+                <a:latin typeface="Times New Roman"/>
+              </a:defRPr>
+            </a:pPr>
+            <a:r>
+              <a:t>•    • In regulated corporate finance, unverified AI outputs are compliance liabilities.</a:t>
+            </a:r>
+          </a:p>
+          <a:p>
+            <a:pPr>
+              <a:spcAft>
+                <a:spcPts val="500"/>
+              </a:spcAft>
+              <a:defRPr sz="1200">
+                <a:solidFill>
+                  <a:srgbClr val="F8FAFC"/>
+                </a:solidFill>
+                <a:latin typeface="Times New Roman"/>
               </a:defRPr>
             </a:pPr>
             <a:r>
@@ -6377,10 +6428,11 @@
               <a:spcAft>
                 <a:spcPts val="500"/>
               </a:spcAft>
-              <a:defRPr sz="1150">
-                <a:solidFill>
-                  <a:srgbClr val="F8FAFC"/>
-                </a:solidFill>
+              <a:defRPr sz="1200">
+                <a:solidFill>
+                  <a:srgbClr val="F8FAFC"/>
+                </a:solidFill>
+                <a:latin typeface="Times New Roman"/>
               </a:defRPr>
             </a:pPr>
             <a:r>
@@ -6392,55 +6444,59 @@
               <a:spcAft>
                 <a:spcPts val="500"/>
               </a:spcAft>
-              <a:defRPr sz="1150">
-                <a:solidFill>
-                  <a:srgbClr val="F8FAFC"/>
-                </a:solidFill>
-              </a:defRPr>
-            </a:pPr>
-            <a:r>
-              <a:t>•      'field_name': 'total_current_liabilities',</a:t>
-            </a:r>
-          </a:p>
-          <a:p>
-            <a:pPr>
-              <a:spcAft>
-                <a:spcPts val="500"/>
-              </a:spcAft>
-              <a:defRPr sz="1150">
-                <a:solidFill>
-                  <a:srgbClr val="F8FAFC"/>
-                </a:solidFill>
-              </a:defRPr>
-            </a:pPr>
-            <a:r>
-              <a:t>•      'extracted_value': 842000.00,</a:t>
-            </a:r>
-          </a:p>
-          <a:p>
-            <a:pPr>
-              <a:spcAft>
-                <a:spcPts val="500"/>
-              </a:spcAft>
-              <a:defRPr sz="1150">
-                <a:solidFill>
-                  <a:srgbClr val="F8FAFC"/>
-                </a:solidFill>
-              </a:defRPr>
-            </a:pPr>
-            <a:r>
-              <a:t>•      'confidence_score': 0.982,</a:t>
-            </a:r>
-          </a:p>
-          <a:p>
-            <a:pPr>
-              <a:spcAft>
-                <a:spcPts val="500"/>
-              </a:spcAft>
-              <a:defRPr sz="1150">
-                <a:solidFill>
-                  <a:srgbClr val="F8FAFC"/>
-                </a:solidFill>
+              <a:defRPr sz="1200">
+                <a:solidFill>
+                  <a:srgbClr val="F8FAFC"/>
+                </a:solidFill>
+                <a:latin typeface="Times New Roman"/>
+              </a:defRPr>
+            </a:pPr>
+            <a:r>
+              <a:t>•      'field': 'total_current_liabilities',</a:t>
+            </a:r>
+          </a:p>
+          <a:p>
+            <a:pPr>
+              <a:spcAft>
+                <a:spcPts val="500"/>
+              </a:spcAft>
+              <a:defRPr sz="1200">
+                <a:solidFill>
+                  <a:srgbClr val="F8FAFC"/>
+                </a:solidFill>
+                <a:latin typeface="Times New Roman"/>
+              </a:defRPr>
+            </a:pPr>
+            <a:r>
+              <a:t>•      'value': 842000.00,</a:t>
+            </a:r>
+          </a:p>
+          <a:p>
+            <a:pPr>
+              <a:spcAft>
+                <a:spcPts val="500"/>
+              </a:spcAft>
+              <a:defRPr sz="1200">
+                <a:solidFill>
+                  <a:srgbClr val="F8FAFC"/>
+                </a:solidFill>
+                <a:latin typeface="Times New Roman"/>
+              </a:defRPr>
+            </a:pPr>
+            <a:r>
+              <a:t>•      'confidence': 0.982,</a:t>
+            </a:r>
+          </a:p>
+          <a:p>
+            <a:pPr>
+              <a:spcAft>
+                <a:spcPts val="500"/>
+              </a:spcAft>
+              <a:defRPr sz="1200">
+                <a:solidFill>
+                  <a:srgbClr val="F8FAFC"/>
+                </a:solidFill>
+                <a:latin typeface="Times New Roman"/>
               </a:defRPr>
             </a:pPr>
             <a:r>
@@ -6452,10 +6508,11 @@
               <a:spcAft>
                 <a:spcPts val="500"/>
               </a:spcAft>
-              <a:defRPr sz="1150">
-                <a:solidFill>
-                  <a:srgbClr val="F8FAFC"/>
-                </a:solidFill>
+              <a:defRPr sz="1200">
+                <a:solidFill>
+                  <a:srgbClr val="F8FAFC"/>
+                </a:solidFill>
+                <a:latin typeface="Times New Roman"/>
               </a:defRPr>
             </a:pPr>
             <a:r>
@@ -6467,40 +6524,27 @@
               <a:spcAft>
                 <a:spcPts val="500"/>
               </a:spcAft>
-              <a:defRPr sz="1150">
-                <a:solidFill>
-                  <a:srgbClr val="F8FAFC"/>
-                </a:solidFill>
-              </a:defRPr>
-            </a:pPr>
-            <a:r>
-              <a:t>•        'source_text': 'TOTAL CURRENT LIABILITIES ... 842,000',</a:t>
-            </a:r>
-          </a:p>
-          <a:p>
-            <a:pPr>
-              <a:spcAft>
-                <a:spcPts val="500"/>
-              </a:spcAft>
-              <a:defRPr sz="1150">
-                <a:solidFill>
-                  <a:srgbClr val="F8FAFC"/>
-                </a:solidFill>
-              </a:defRPr>
-            </a:pPr>
-            <a:r>
-              <a:t>•        'bounding_box': [140, 620, 510, 642]</a:t>
-            </a:r>
-          </a:p>
-          <a:p>
-            <a:pPr>
-              <a:spcAft>
-                <a:spcPts val="500"/>
-              </a:spcAft>
-              <a:defRPr sz="1150">
-                <a:solidFill>
-                  <a:srgbClr val="F8FAFC"/>
-                </a:solidFill>
+              <a:defRPr sz="1200">
+                <a:solidFill>
+                  <a:srgbClr val="F8FAFC"/>
+                </a:solidFill>
+                <a:latin typeface="Times New Roman"/>
+              </a:defRPr>
+            </a:pPr>
+            <a:r>
+              <a:t>•        'source_text': 'TOTAL CURRENT LIABILITIES ... 842,000'</a:t>
+            </a:r>
+          </a:p>
+          <a:p>
+            <a:pPr>
+              <a:spcAft>
+                <a:spcPts val="500"/>
+              </a:spcAft>
+              <a:defRPr sz="1200">
+                <a:solidFill>
+                  <a:srgbClr val="F8FAFC"/>
+                </a:solidFill>
+                <a:latin typeface="Times New Roman"/>
               </a:defRPr>
             </a:pPr>
             <a:r>
@@ -6512,10 +6556,11 @@
               <a:spcAft>
                 <a:spcPts val="500"/>
               </a:spcAft>
-              <a:defRPr sz="1150">
-                <a:solidFill>
-                  <a:srgbClr val="F8FAFC"/>
-                </a:solidFill>
+              <a:defRPr sz="1200">
+                <a:solidFill>
+                  <a:srgbClr val="F8FAFC"/>
+                </a:solidFill>
+                <a:latin typeface="Times New Roman"/>
               </a:defRPr>
             </a:pPr>
             <a:r>
@@ -6527,14 +6572,15 @@
               <a:spcAft>
                 <a:spcPts val="500"/>
               </a:spcAft>
-              <a:defRPr sz="1150">
-                <a:solidFill>
-                  <a:srgbClr val="F8FAFC"/>
-                </a:solidFill>
-              </a:defRPr>
-            </a:pPr>
-            <a:r>
-              <a:t>•    • Auditors verify numbers in 5 seconds without reading 30-page PDFs.</a:t>
+              <a:defRPr sz="1200">
+                <a:solidFill>
+                  <a:srgbClr val="F8FAFC"/>
+                </a:solidFill>
+                <a:latin typeface="Times New Roman"/>
+              </a:defRPr>
+            </a:pPr>
+            <a:r>
+              <a:t>•    • Auditors verify numbers in 5 seconds without reading 30-page reports.</a:t>
             </a:r>
           </a:p>
         </p:txBody>
@@ -6610,10 +6656,11 @@
               <a:spcAft>
                 <a:spcPts val="800"/>
               </a:spcAft>
-              <a:defRPr sz="1400" b="1">
+              <a:defRPr sz="1500" b="1">
                 <a:solidFill>
                   <a:srgbClr val="34D399"/>
                 </a:solidFill>
+                <a:latin typeface="Times New Roman"/>
               </a:defRPr>
             </a:pPr>
             <a:r>
@@ -6625,10 +6672,11 @@
               <a:spcAft>
                 <a:spcPts val="500"/>
               </a:spcAft>
-              <a:defRPr sz="1150">
-                <a:solidFill>
-                  <a:srgbClr val="F8FAFC"/>
-                </a:solidFill>
+              <a:defRPr sz="1200">
+                <a:solidFill>
+                  <a:srgbClr val="F8FAFC"/>
+                </a:solidFill>
+                <a:latin typeface="Times New Roman"/>
               </a:defRPr>
             </a:pPr>
             <a:r>
@@ -6640,40 +6688,27 @@
               <a:spcAft>
                 <a:spcPts val="500"/>
               </a:spcAft>
-              <a:defRPr sz="1150">
-                <a:solidFill>
-                  <a:srgbClr val="F8FAFC"/>
-                </a:solidFill>
-              </a:defRPr>
-            </a:pPr>
-            <a:r>
-              <a:t>•    • Embedded real-time document renderer (PDF, PNG, JPG).</a:t>
-            </a:r>
-          </a:p>
-          <a:p>
-            <a:pPr>
-              <a:spcAft>
-                <a:spcPts val="500"/>
-              </a:spcAft>
-              <a:defRPr sz="1150">
-                <a:solidFill>
-                  <a:srgbClr val="F8FAFC"/>
-                </a:solidFill>
-              </a:defRPr>
-            </a:pPr>
-            <a:r>
-              <a:t>•    • Zero reliance on external PDF viewer plugins.</a:t>
-            </a:r>
-          </a:p>
-          <a:p>
-            <a:pPr>
-              <a:spcAft>
-                <a:spcPts val="500"/>
-              </a:spcAft>
-              <a:defRPr sz="1150">
-                <a:solidFill>
-                  <a:srgbClr val="F8FAFC"/>
-                </a:solidFill>
+              <a:defRPr sz="1200">
+                <a:solidFill>
+                  <a:srgbClr val="F8FAFC"/>
+                </a:solidFill>
+                <a:latin typeface="Times New Roman"/>
+              </a:defRPr>
+            </a:pPr>
+            <a:r>
+              <a:t>•    • Real-time embedded PDF renderer with page navigation.</a:t>
+            </a:r>
+          </a:p>
+          <a:p>
+            <a:pPr>
+              <a:spcAft>
+                <a:spcPts val="500"/>
+              </a:spcAft>
+              <a:defRPr sz="1200">
+                <a:solidFill>
+                  <a:srgbClr val="F8FAFC"/>
+                </a:solidFill>
+                <a:latin typeface="Times New Roman"/>
               </a:defRPr>
             </a:pPr>
             <a:r>
@@ -6685,10 +6720,11 @@
               <a:spcAft>
                 <a:spcPts val="500"/>
               </a:spcAft>
-              <a:defRPr sz="1150">
-                <a:solidFill>
-                  <a:srgbClr val="F8FAFC"/>
-                </a:solidFill>
+              <a:defRPr sz="1200">
+                <a:solidFill>
+                  <a:srgbClr val="F8FAFC"/>
+                </a:solidFill>
+                <a:latin typeface="Times New Roman"/>
               </a:defRPr>
             </a:pPr>
             <a:r>
@@ -6700,70 +6736,75 @@
               <a:spcAft>
                 <a:spcPts val="500"/>
               </a:spcAft>
-              <a:defRPr sz="1150">
-                <a:solidFill>
-                  <a:srgbClr val="F8FAFC"/>
-                </a:solidFill>
-              </a:defRPr>
-            </a:pPr>
-            <a:r>
-              <a:t>•    • Entity Tab: Extracted scalar figures with confidence score badges.</a:t>
-            </a:r>
-          </a:p>
-          <a:p>
-            <a:pPr>
-              <a:spcAft>
-                <a:spcPts val="500"/>
-              </a:spcAft>
-              <a:defRPr sz="1150">
-                <a:solidFill>
-                  <a:srgbClr val="F8FAFC"/>
-                </a:solidFill>
-              </a:defRPr>
-            </a:pPr>
-            <a:r>
-              <a:t>•    • Tables Tab: Structured multi-column financial grids.</a:t>
-            </a:r>
-          </a:p>
-          <a:p>
-            <a:pPr>
-              <a:spcAft>
-                <a:spcPts val="500"/>
-              </a:spcAft>
-              <a:defRPr sz="1150">
-                <a:solidFill>
-                  <a:srgbClr val="F8FAFC"/>
-                </a:solidFill>
-              </a:defRPr>
-            </a:pPr>
-            <a:r>
-              <a:t>•    • Validations Tab: Visual Green/Red mathematical invariant cards.</a:t>
-            </a:r>
-          </a:p>
-          <a:p>
-            <a:pPr>
-              <a:spcAft>
-                <a:spcPts val="500"/>
-              </a:spcAft>
-              <a:defRPr sz="1150">
-                <a:solidFill>
-                  <a:srgbClr val="F8FAFC"/>
-                </a:solidFill>
-              </a:defRPr>
-            </a:pPr>
-            <a:r>
-              <a:t>•    • Provenance Tab: Clickable citations linking to exact source pages.</a:t>
-            </a:r>
-          </a:p>
-          <a:p>
-            <a:pPr>
-              <a:spcAft>
-                <a:spcPts val="500"/>
-              </a:spcAft>
-              <a:defRPr sz="1150">
-                <a:solidFill>
-                  <a:srgbClr val="F8FAFC"/>
-                </a:solidFill>
+              <a:defRPr sz="1200">
+                <a:solidFill>
+                  <a:srgbClr val="F8FAFC"/>
+                </a:solidFill>
+                <a:latin typeface="Times New Roman"/>
+              </a:defRPr>
+            </a:pPr>
+            <a:r>
+              <a:t>•    • Entities Tab: Extracted scalar values with individual confidence badges.</a:t>
+            </a:r>
+          </a:p>
+          <a:p>
+            <a:pPr>
+              <a:spcAft>
+                <a:spcPts val="500"/>
+              </a:spcAft>
+              <a:defRPr sz="1200">
+                <a:solidFill>
+                  <a:srgbClr val="F8FAFC"/>
+                </a:solidFill>
+                <a:latin typeface="Times New Roman"/>
+              </a:defRPr>
+            </a:pPr>
+            <a:r>
+              <a:t>•    • Tables Tab: Reconstructed multi-period financial grids.</a:t>
+            </a:r>
+          </a:p>
+          <a:p>
+            <a:pPr>
+              <a:spcAft>
+                <a:spcPts val="500"/>
+              </a:spcAft>
+              <a:defRPr sz="1200">
+                <a:solidFill>
+                  <a:srgbClr val="F8FAFC"/>
+                </a:solidFill>
+                <a:latin typeface="Times New Roman"/>
+              </a:defRPr>
+            </a:pPr>
+            <a:r>
+              <a:t>•    • Validations Tab: Green/Red mathematical invariant audit cards.</a:t>
+            </a:r>
+          </a:p>
+          <a:p>
+            <a:pPr>
+              <a:spcAft>
+                <a:spcPts val="500"/>
+              </a:spcAft>
+              <a:defRPr sz="1200">
+                <a:solidFill>
+                  <a:srgbClr val="F8FAFC"/>
+                </a:solidFill>
+                <a:latin typeface="Times New Roman"/>
+              </a:defRPr>
+            </a:pPr>
+            <a:r>
+              <a:t>•    • Provenance Tab: Clickable citations linking to source page context.</a:t>
+            </a:r>
+          </a:p>
+          <a:p>
+            <a:pPr>
+              <a:spcAft>
+                <a:spcPts val="500"/>
+              </a:spcAft>
+              <a:defRPr sz="1200">
+                <a:solidFill>
+                  <a:srgbClr val="F8FAFC"/>
+                </a:solidFill>
+                <a:latin typeface="Times New Roman"/>
               </a:defRPr>
             </a:pPr>
             <a:r>
@@ -6775,14 +6816,15 @@
               <a:spcAft>
                 <a:spcPts val="500"/>
               </a:spcAft>
-              <a:defRPr sz="1150">
-                <a:solidFill>
-                  <a:srgbClr val="F8FAFC"/>
-                </a:solidFill>
-              </a:defRPr>
-            </a:pPr>
-            <a:r>
-              <a:t>• UX Benchmark: Matches enterprise tooling like AWS Textract &amp; ABBYY.</a:t>
+              <a:defRPr sz="1200">
+                <a:solidFill>
+                  <a:srgbClr val="F8FAFC"/>
+                </a:solidFill>
+                <a:latin typeface="Times New Roman"/>
+              </a:defRPr>
+            </a:pPr>
+            <a:r>
+              <a:t>• UX Benchmark: Matches enterprise tooling like AWS Textract and ABBYY.</a:t>
             </a:r>
           </a:p>
         </p:txBody>
@@ -6820,7 +6862,7 @@
             <a:avLst/>
           </a:prstGeom>
           <a:solidFill>
-            <a:srgbClr val="0A0E17"/>
+            <a:srgbClr val="0B0F19"/>
           </a:solidFill>
           <a:ln>
             <a:noFill/>
@@ -6888,10 +6930,11 @@
           <a:lstStyle/>
           <a:p>
             <a:pPr algn="ctr">
-              <a:defRPr sz="950" b="1">
+              <a:defRPr sz="1000" b="1">
                 <a:solidFill>
                   <a:srgbClr val="93C5FD"/>
                 </a:solidFill>
+                <a:latin typeface="Times New Roman"/>
               </a:defRPr>
             </a:pPr>
             <a:r>
@@ -6923,10 +6966,11 @@
           <a:lstStyle/>
           <a:p>
             <a:pPr>
-              <a:defRPr sz="2100" b="1">
-                <a:solidFill>
-                  <a:srgbClr val="F8FAFC"/>
-                </a:solidFill>
+              <a:defRPr sz="2200" b="1">
+                <a:solidFill>
+                  <a:srgbClr val="F8FAFC"/>
+                </a:solidFill>
+                <a:latin typeface="Times New Roman"/>
               </a:defRPr>
             </a:pPr>
             <a:r>
@@ -6958,14 +7002,15 @@
           <a:lstStyle/>
           <a:p>
             <a:pPr algn="r">
-              <a:defRPr sz="1100" b="1">
+              <a:defRPr sz="1200" b="1">
                 <a:solidFill>
                   <a:srgbClr val="94A3B8"/>
                 </a:solidFill>
-              </a:defRPr>
-            </a:pPr>
-            <a:r>
-              <a:t>07/09</a:t>
+                <a:latin typeface="Times New Roman"/>
+              </a:defRPr>
+            </a:pPr>
+            <a:r>
+              <a:t>07/08</a:t>
             </a:r>
           </a:p>
         </p:txBody>
@@ -6979,8 +7024,8 @@
           <p:nvPr/>
         </p:nvGraphicFramePr>
         <p:xfrm>
-          <a:off x="731520" y="1645920"/>
-          <a:ext cx="10698480" cy="2560320"/>
+          <a:off x="731520" y="1554480"/>
+          <a:ext cx="10698480" cy="2468880"/>
         </p:xfrm>
         <a:graphic>
           <a:graphicData uri="http://schemas.openxmlformats.org/drawingml/2006/table">
@@ -6995,7 +7040,7 @@
                 <a:gridCol w="2139696"/>
                 <a:gridCol w="2139696"/>
               </a:tblGrid>
-              <a:tr h="426720">
+              <a:tr h="411480">
                 <a:tc>
                   <a:txBody>
                     <a:bodyPr/>
@@ -7006,6 +7051,7 @@
                           <a:solidFill>
                             <a:srgbClr val="38BDF8"/>
                           </a:solidFill>
+                          <a:latin typeface="Times New Roman"/>
                         </a:defRPr>
                       </a:pPr>
                       <a:r>
@@ -7029,6 +7075,7 @@
                           <a:solidFill>
                             <a:srgbClr val="38BDF8"/>
                           </a:solidFill>
+                          <a:latin typeface="Times New Roman"/>
                         </a:defRPr>
                       </a:pPr>
                       <a:r>
@@ -7052,6 +7099,7 @@
                           <a:solidFill>
                             <a:srgbClr val="38BDF8"/>
                           </a:solidFill>
+                          <a:latin typeface="Times New Roman"/>
                         </a:defRPr>
                       </a:pPr>
                       <a:r>
@@ -7075,6 +7123,7 @@
                           <a:solidFill>
                             <a:srgbClr val="38BDF8"/>
                           </a:solidFill>
+                          <a:latin typeface="Times New Roman"/>
                         </a:defRPr>
                       </a:pPr>
                       <a:r>
@@ -7098,6 +7147,7 @@
                           <a:solidFill>
                             <a:srgbClr val="38BDF8"/>
                           </a:solidFill>
+                          <a:latin typeface="Times New Roman"/>
                         </a:defRPr>
                       </a:pPr>
                       <a:r>
@@ -7112,7 +7162,7 @@
                   </a:tcPr>
                 </a:tc>
               </a:tr>
-              <a:tr h="426720">
+              <a:tr h="411480">
                 <a:tc>
                   <a:txBody>
                     <a:bodyPr/>
@@ -7123,6 +7173,7 @@
                           <a:solidFill>
                             <a:srgbClr val="F8FAFC"/>
                           </a:solidFill>
+                          <a:latin typeface="Times New Roman"/>
                         </a:defRPr>
                       </a:pPr>
                       <a:r>
@@ -7146,6 +7197,7 @@
                           <a:solidFill>
                             <a:srgbClr val="F8FAFC"/>
                           </a:solidFill>
+                          <a:latin typeface="Times New Roman"/>
                         </a:defRPr>
                       </a:pPr>
                       <a:r>
@@ -7169,6 +7221,7 @@
                           <a:solidFill>
                             <a:srgbClr val="F8FAFC"/>
                           </a:solidFill>
+                          <a:latin typeface="Times New Roman"/>
                         </a:defRPr>
                       </a:pPr>
                       <a:r>
@@ -7192,6 +7245,7 @@
                           <a:solidFill>
                             <a:srgbClr val="F8FAFC"/>
                           </a:solidFill>
+                          <a:latin typeface="Times New Roman"/>
                         </a:defRPr>
                       </a:pPr>
                       <a:r>
@@ -7215,6 +7269,7 @@
                           <a:solidFill>
                             <a:srgbClr val="F8FAFC"/>
                           </a:solidFill>
+                          <a:latin typeface="Times New Roman"/>
                         </a:defRPr>
                       </a:pPr>
                       <a:r>
@@ -7229,7 +7284,7 @@
                   </a:tcPr>
                 </a:tc>
               </a:tr>
-              <a:tr h="426720">
+              <a:tr h="411480">
                 <a:tc>
                   <a:txBody>
                     <a:bodyPr/>
@@ -7240,6 +7295,7 @@
                           <a:solidFill>
                             <a:srgbClr val="F8FAFC"/>
                           </a:solidFill>
+                          <a:latin typeface="Times New Roman"/>
                         </a:defRPr>
                       </a:pPr>
                       <a:r>
@@ -7263,6 +7319,7 @@
                           <a:solidFill>
                             <a:srgbClr val="F8FAFC"/>
                           </a:solidFill>
+                          <a:latin typeface="Times New Roman"/>
                         </a:defRPr>
                       </a:pPr>
                       <a:r>
@@ -7286,6 +7343,7 @@
                           <a:solidFill>
                             <a:srgbClr val="F8FAFC"/>
                           </a:solidFill>
+                          <a:latin typeface="Times New Roman"/>
                         </a:defRPr>
                       </a:pPr>
                       <a:r>
@@ -7309,6 +7367,7 @@
                           <a:solidFill>
                             <a:srgbClr val="F8FAFC"/>
                           </a:solidFill>
+                          <a:latin typeface="Times New Roman"/>
                         </a:defRPr>
                       </a:pPr>
                       <a:r>
@@ -7332,6 +7391,7 @@
                           <a:solidFill>
                             <a:srgbClr val="F8FAFC"/>
                           </a:solidFill>
+                          <a:latin typeface="Times New Roman"/>
                         </a:defRPr>
                       </a:pPr>
                       <a:r>
@@ -7346,7 +7406,7 @@
                   </a:tcPr>
                 </a:tc>
               </a:tr>
-              <a:tr h="426720">
+              <a:tr h="411480">
                 <a:tc>
                   <a:txBody>
                     <a:bodyPr/>
@@ -7357,6 +7417,7 @@
                           <a:solidFill>
                             <a:srgbClr val="F8FAFC"/>
                           </a:solidFill>
+                          <a:latin typeface="Times New Roman"/>
                         </a:defRPr>
                       </a:pPr>
                       <a:r>
@@ -7380,6 +7441,7 @@
                           <a:solidFill>
                             <a:srgbClr val="F8FAFC"/>
                           </a:solidFill>
+                          <a:latin typeface="Times New Roman"/>
                         </a:defRPr>
                       </a:pPr>
                       <a:r>
@@ -7403,6 +7465,7 @@
                           <a:solidFill>
                             <a:srgbClr val="F8FAFC"/>
                           </a:solidFill>
+                          <a:latin typeface="Times New Roman"/>
                         </a:defRPr>
                       </a:pPr>
                       <a:r>
@@ -7426,6 +7489,7 @@
                           <a:solidFill>
                             <a:srgbClr val="F8FAFC"/>
                           </a:solidFill>
+                          <a:latin typeface="Times New Roman"/>
                         </a:defRPr>
                       </a:pPr>
                       <a:r>
@@ -7449,6 +7513,7 @@
                           <a:solidFill>
                             <a:srgbClr val="F8FAFC"/>
                           </a:solidFill>
+                          <a:latin typeface="Times New Roman"/>
                         </a:defRPr>
                       </a:pPr>
                       <a:r>
@@ -7463,7 +7528,7 @@
                   </a:tcPr>
                 </a:tc>
               </a:tr>
-              <a:tr h="426720">
+              <a:tr h="411480">
                 <a:tc>
                   <a:txBody>
                     <a:bodyPr/>
@@ -7474,6 +7539,7 @@
                           <a:solidFill>
                             <a:srgbClr val="F8FAFC"/>
                           </a:solidFill>
+                          <a:latin typeface="Times New Roman"/>
                         </a:defRPr>
                       </a:pPr>
                       <a:r>
@@ -7497,6 +7563,7 @@
                           <a:solidFill>
                             <a:srgbClr val="F8FAFC"/>
                           </a:solidFill>
+                          <a:latin typeface="Times New Roman"/>
                         </a:defRPr>
                       </a:pPr>
                       <a:r>
@@ -7520,6 +7587,7 @@
                           <a:solidFill>
                             <a:srgbClr val="F8FAFC"/>
                           </a:solidFill>
+                          <a:latin typeface="Times New Roman"/>
                         </a:defRPr>
                       </a:pPr>
                       <a:r>
@@ -7543,10 +7611,11 @@
                           <a:solidFill>
                             <a:srgbClr val="F8FAFC"/>
                           </a:solidFill>
+                          <a:latin typeface="Times New Roman"/>
                         </a:defRPr>
                       </a:pPr>
                       <a:r>
-                        <a:t>Discrepancy Audited</a:t>
+                        <a:t>Discrepancies Flagged</a:t>
                       </a:r>
                     </a:p>
                   </a:txBody>
@@ -7566,6 +7635,7 @@
                           <a:solidFill>
                             <a:srgbClr val="F8FAFC"/>
                           </a:solidFill>
+                          <a:latin typeface="Times New Roman"/>
                         </a:defRPr>
                       </a:pPr>
                       <a:r>
@@ -7580,7 +7650,7 @@
                   </a:tcPr>
                 </a:tc>
               </a:tr>
-              <a:tr h="426720">
+              <a:tr h="411480">
                 <a:tc>
                   <a:txBody>
                     <a:bodyPr/>
@@ -7591,6 +7661,7 @@
                           <a:solidFill>
                             <a:srgbClr val="34D399"/>
                           </a:solidFill>
+                          <a:latin typeface="Times New Roman"/>
                         </a:defRPr>
                       </a:pPr>
                       <a:r>
@@ -7614,6 +7685,7 @@
                           <a:solidFill>
                             <a:srgbClr val="34D399"/>
                           </a:solidFill>
+                          <a:latin typeface="Times New Roman"/>
                         </a:defRPr>
                       </a:pPr>
                       <a:r>
@@ -7637,6 +7709,7 @@
                           <a:solidFill>
                             <a:srgbClr val="34D399"/>
                           </a:solidFill>
+                          <a:latin typeface="Times New Roman"/>
                         </a:defRPr>
                       </a:pPr>
                       <a:r>
@@ -7660,6 +7733,7 @@
                           <a:solidFill>
                             <a:srgbClr val="34D399"/>
                           </a:solidFill>
+                          <a:latin typeface="Times New Roman"/>
                         </a:defRPr>
                       </a:pPr>
                       <a:r>
@@ -7683,6 +7757,7 @@
                           <a:solidFill>
                             <a:srgbClr val="34D399"/>
                           </a:solidFill>
+                          <a:latin typeface="Times New Roman"/>
                         </a:defRPr>
                       </a:pPr>
                       <a:r>
@@ -7709,8 +7784,8 @@
         </p:nvSpPr>
         <p:spPr>
           <a:xfrm>
-            <a:off x="731520" y="4389120"/>
-            <a:ext cx="10698480" cy="1920240"/>
+            <a:off x="731520" y="4297680"/>
+            <a:ext cx="10698480" cy="2011680"/>
           </a:xfrm>
           <a:prstGeom prst="roundRect">
             <a:avLst/>
@@ -7754,8 +7829,8 @@
         </p:nvSpPr>
         <p:spPr>
           <a:xfrm>
-            <a:off x="960120" y="4572000"/>
-            <a:ext cx="10241280" cy="1554480"/>
+            <a:off x="960120" y="4480560"/>
+            <a:ext cx="10241280" cy="1645920"/>
           </a:xfrm>
           <a:prstGeom prst="rect">
             <a:avLst/>
@@ -7772,25 +7847,27 @@
               <a:spcAft>
                 <a:spcPts val="800"/>
               </a:spcAft>
-              <a:defRPr sz="1400" b="1">
+              <a:defRPr sz="1500" b="1">
                 <a:solidFill>
                   <a:srgbClr val="34D399"/>
                 </a:solidFill>
-              </a:defRPr>
-            </a:pPr>
-            <a:r>
-              <a:t>Automated Pytest Suite &amp; Reproducibility  · [Pytest QA]</a:t>
-            </a:r>
-          </a:p>
-          <a:p>
-            <a:pPr>
-              <a:spcAft>
-                <a:spcPts val="500"/>
-              </a:spcAft>
-              <a:defRPr sz="1150">
-                <a:solidFill>
-                  <a:srgbClr val="F8FAFC"/>
-                </a:solidFill>
+                <a:latin typeface="Times New Roman"/>
+              </a:defRPr>
+            </a:pPr>
+            <a:r>
+              <a:t>Automated Pytest Suite &amp; Reproducibility (10/10 Passing)  · [Pytest QA]</a:t>
+            </a:r>
+          </a:p>
+          <a:p>
+            <a:pPr>
+              <a:spcAft>
+                <a:spcPts val="500"/>
+              </a:spcAft>
+              <a:defRPr sz="1200">
+                <a:solidFill>
+                  <a:srgbClr val="F8FAFC"/>
+                </a:solidFill>
+                <a:latin typeface="Times New Roman"/>
               </a:defRPr>
             </a:pPr>
             <a:r>
@@ -7802,10 +7879,11 @@
               <a:spcAft>
                 <a:spcPts val="500"/>
               </a:spcAft>
-              <a:defRPr sz="1150">
-                <a:solidFill>
-                  <a:srgbClr val="F8FAFC"/>
-                </a:solidFill>
+              <a:defRPr sz="1200">
+                <a:solidFill>
+                  <a:srgbClr val="F8FAFC"/>
+                </a:solidFill>
+                <a:latin typeface="Times New Roman"/>
               </a:defRPr>
             </a:pPr>
             <a:r>
@@ -7817,10 +7895,11 @@
               <a:spcAft>
                 <a:spcPts val="500"/>
               </a:spcAft>
-              <a:defRPr sz="1150">
-                <a:solidFill>
-                  <a:srgbClr val="F8FAFC"/>
-                </a:solidFill>
+              <a:defRPr sz="1200">
+                <a:solidFill>
+                  <a:srgbClr val="F8FAFC"/>
+                </a:solidFill>
+                <a:latin typeface="Times New Roman"/>
               </a:defRPr>
             </a:pPr>
             <a:r>
@@ -7832,14 +7911,15 @@
               <a:spcAft>
                 <a:spcPts val="500"/>
               </a:spcAft>
-              <a:defRPr sz="1150">
-                <a:solidFill>
-                  <a:srgbClr val="F8FAFC"/>
-                </a:solidFill>
-              </a:defRPr>
-            </a:pPr>
-            <a:r>
-              <a:t>•   • Reproducible Command: `pytest tests -v`  |  Benchmark Runner: `python scripts/benchmark_dataset.py`</a:t>
+              <a:defRPr sz="1200">
+                <a:solidFill>
+                  <a:srgbClr val="F8FAFC"/>
+                </a:solidFill>
+                <a:latin typeface="Times New Roman"/>
+              </a:defRPr>
+            </a:pPr>
+            <a:r>
+              <a:t>•   • Reproducibility: Run anytime via `pytest tests -v`  |  Benchmark Runner: `python scripts/benchmark_dataset.py`</a:t>
             </a:r>
           </a:p>
         </p:txBody>
@@ -7877,7 +7957,7 @@
             <a:avLst/>
           </a:prstGeom>
           <a:solidFill>
-            <a:srgbClr val="0A0E17"/>
+            <a:srgbClr val="0B0F19"/>
           </a:solidFill>
           <a:ln>
             <a:noFill/>
@@ -7945,14 +8025,15 @@
           <a:lstStyle/>
           <a:p>
             <a:pPr algn="ctr">
-              <a:defRPr sz="950" b="1">
+              <a:defRPr sz="1000" b="1">
                 <a:solidFill>
                   <a:srgbClr val="93C5FD"/>
                 </a:solidFill>
-              </a:defRPr>
-            </a:pPr>
-            <a:r>
-              <a:t>DEVOPS &amp; CLOUD</a:t>
+                <a:latin typeface="Times New Roman"/>
+              </a:defRPr>
+            </a:pPr>
+            <a:r>
+              <a:t>DEVOPS &amp; SCALABILITY</a:t>
             </a:r>
           </a:p>
         </p:txBody>
@@ -7980,14 +8061,15 @@
           <a:lstStyle/>
           <a:p>
             <a:pPr>
-              <a:defRPr sz="2100" b="1">
-                <a:solidFill>
-                  <a:srgbClr val="F8FAFC"/>
-                </a:solidFill>
-              </a:defRPr>
-            </a:pPr>
-            <a:r>
-              <a:t>Docker Containerization, Render Cloud, &amp; OpenAPI Standards</a:t>
+              <a:defRPr sz="2200" b="1">
+                <a:solidFill>
+                  <a:srgbClr val="F8FAFC"/>
+                </a:solidFill>
+                <a:latin typeface="Times New Roman"/>
+              </a:defRPr>
+            </a:pPr>
+            <a:r>
+              <a:t>Production Deployment, 10M Docs Scale &amp; Conclusion</a:t>
             </a:r>
           </a:p>
         </p:txBody>
@@ -8015,14 +8097,15 @@
           <a:lstStyle/>
           <a:p>
             <a:pPr algn="r">
-              <a:defRPr sz="1100" b="1">
+              <a:defRPr sz="1200" b="1">
                 <a:solidFill>
                   <a:srgbClr val="94A3B8"/>
                 </a:solidFill>
-              </a:defRPr>
-            </a:pPr>
-            <a:r>
-              <a:t>08/09</a:t>
+                <a:latin typeface="Times New Roman"/>
+              </a:defRPr>
+            </a:pPr>
+            <a:r>
+              <a:t>08/08</a:t>
             </a:r>
           </a:p>
         </p:txBody>
@@ -8098,10 +8181,11 @@
               <a:spcAft>
                 <a:spcPts val="800"/>
               </a:spcAft>
-              <a:defRPr sz="1400" b="1">
+              <a:defRPr sz="1500" b="1">
                 <a:solidFill>
                   <a:srgbClr val="38BDF8"/>
                 </a:solidFill>
+                <a:latin typeface="Times New Roman"/>
               </a:defRPr>
             </a:pPr>
             <a:r>
@@ -8113,10 +8197,11 @@
               <a:spcAft>
                 <a:spcPts val="500"/>
               </a:spcAft>
-              <a:defRPr sz="1150">
-                <a:solidFill>
-                  <a:srgbClr val="F8FAFC"/>
-                </a:solidFill>
+              <a:defRPr sz="1200">
+                <a:solidFill>
+                  <a:srgbClr val="F8FAFC"/>
+                </a:solidFill>
+                <a:latin typeface="Times New Roman"/>
               </a:defRPr>
             </a:pPr>
             <a:r>
@@ -8128,55 +8213,43 @@
               <a:spcAft>
                 <a:spcPts val="500"/>
               </a:spcAft>
-              <a:defRPr sz="1150">
-                <a:solidFill>
-                  <a:srgbClr val="F8FAFC"/>
-                </a:solidFill>
-              </a:defRPr>
-            </a:pPr>
-            <a:r>
-              <a:t>•    • Base: python:3.11-slim (minimal Linux footprint, reduced CVE surface).</a:t>
-            </a:r>
-          </a:p>
-          <a:p>
-            <a:pPr>
-              <a:spcAft>
-                <a:spcPts val="500"/>
-              </a:spcAft>
-              <a:defRPr sz="1150">
-                <a:solidFill>
-                  <a:srgbClr val="F8FAFC"/>
-                </a:solidFill>
-              </a:defRPr>
-            </a:pPr>
-            <a:r>
-              <a:t>•    • Zero C++ binary bloat (no apt-get tesseract or poppler).</a:t>
-            </a:r>
-          </a:p>
-          <a:p>
-            <a:pPr>
-              <a:spcAft>
-                <a:spcPts val="500"/>
-              </a:spcAft>
-              <a:defRPr sz="1150">
-                <a:solidFill>
-                  <a:srgbClr val="F8FAFC"/>
-                </a:solidFill>
-              </a:defRPr>
-            </a:pPr>
-            <a:r>
-              <a:t>•    • Integrated HEALTHCHECK probe running curl -f http://localhost:8000/health.</a:t>
-            </a:r>
-          </a:p>
-          <a:p>
-            <a:pPr>
-              <a:spcAft>
-                <a:spcPts val="500"/>
-              </a:spcAft>
-              <a:defRPr sz="1150">
-                <a:solidFill>
-                  <a:srgbClr val="F8FAFC"/>
-                </a:solidFill>
+              <a:defRPr sz="1200">
+                <a:solidFill>
+                  <a:srgbClr val="F8FAFC"/>
+                </a:solidFill>
+                <a:latin typeface="Times New Roman"/>
+              </a:defRPr>
+            </a:pPr>
+            <a:r>
+              <a:t>•    • Base: python:3.11-slim with zero apt-get C++ binary dependencies.</a:t>
+            </a:r>
+          </a:p>
+          <a:p>
+            <a:pPr>
+              <a:spcAft>
+                <a:spcPts val="500"/>
+              </a:spcAft>
+              <a:defRPr sz="1200">
+                <a:solidFill>
+                  <a:srgbClr val="F8FAFC"/>
+                </a:solidFill>
+                <a:latin typeface="Times New Roman"/>
+              </a:defRPr>
+            </a:pPr>
+            <a:r>
+              <a:t>•    • Automated health check probe running curl -f http://localhost:8000/health every 30s.</a:t>
+            </a:r>
+          </a:p>
+          <a:p>
+            <a:pPr>
+              <a:spcAft>
+                <a:spcPts val="500"/>
+              </a:spcAft>
+              <a:defRPr sz="1200">
+                <a:solidFill>
+                  <a:srgbClr val="F8FAFC"/>
+                </a:solidFill>
+                <a:latin typeface="Times New Roman"/>
               </a:defRPr>
             </a:pPr>
             <a:r>
@@ -8188,10 +8261,11 @@
               <a:spcAft>
                 <a:spcPts val="500"/>
               </a:spcAft>
-              <a:defRPr sz="1150">
-                <a:solidFill>
-                  <a:srgbClr val="F8FAFC"/>
-                </a:solidFill>
+              <a:defRPr sz="1200">
+                <a:solidFill>
+                  <a:srgbClr val="F8FAFC"/>
+                </a:solidFill>
+                <a:latin typeface="Times New Roman"/>
               </a:defRPr>
             </a:pPr>
             <a:r>
@@ -8203,10 +8277,11 @@
               <a:spcAft>
                 <a:spcPts val="500"/>
               </a:spcAft>
-              <a:defRPr sz="1150">
-                <a:solidFill>
-                  <a:srgbClr val="F8FAFC"/>
-                </a:solidFill>
+              <a:defRPr sz="1200">
+                <a:solidFill>
+                  <a:srgbClr val="F8FAFC"/>
+                </a:solidFill>
+                <a:latin typeface="Times New Roman"/>
               </a:defRPr>
             </a:pPr>
             <a:r>
@@ -8218,44 +8293,31 @@
               <a:spcAft>
                 <a:spcPts val="500"/>
               </a:spcAft>
-              <a:defRPr sz="1150">
-                <a:solidFill>
-                  <a:srgbClr val="F8FAFC"/>
-                </a:solidFill>
-              </a:defRPr>
-            </a:pPr>
-            <a:r>
-              <a:t>•    • Environment: Python 3.11 / Uvicorn ASGI Server.</a:t>
-            </a:r>
-          </a:p>
-          <a:p>
-            <a:pPr>
-              <a:spcAft>
-                <a:spcPts val="500"/>
-              </a:spcAft>
-              <a:defRPr sz="1150">
-                <a:solidFill>
-                  <a:srgbClr val="F8FAFC"/>
-                </a:solidFill>
-              </a:defRPr>
-            </a:pPr>
-            <a:r>
-              <a:t>•    • Dynamic PORT binding and automated GitHub CI/CD sync.</a:t>
-            </a:r>
-          </a:p>
-          <a:p>
-            <a:pPr>
-              <a:spcAft>
-                <a:spcPts val="500"/>
-              </a:spcAft>
-              <a:defRPr sz="1150">
-                <a:solidFill>
-                  <a:srgbClr val="F8FAFC"/>
-                </a:solidFill>
-              </a:defRPr>
-            </a:pPr>
-            <a:r>
-              <a:t>•    • Verified live: HTTP 200 OK on both Web Dashboard and API routes.</a:t>
+              <a:defRPr sz="1200">
+                <a:solidFill>
+                  <a:srgbClr val="F8FAFC"/>
+                </a:solidFill>
+                <a:latin typeface="Times New Roman"/>
+              </a:defRPr>
+            </a:pPr>
+            <a:r>
+              <a:t>•    • Standardized OpenAPI Swagger docs at /docs and ReDoc at /redoc.</a:t>
+            </a:r>
+          </a:p>
+          <a:p>
+            <a:pPr>
+              <a:spcAft>
+                <a:spcPts val="500"/>
+              </a:spcAft>
+              <a:defRPr sz="1200">
+                <a:solidFill>
+                  <a:srgbClr val="F8FAFC"/>
+                </a:solidFill>
+                <a:latin typeface="Times New Roman"/>
+              </a:defRPr>
+            </a:pPr>
+            <a:r>
+              <a:t>•    • Verified live: HTTP 200 OK on both Web Dashboard and REST routes.</a:t>
             </a:r>
           </a:p>
         </p:txBody>
@@ -8331,100 +8393,91 @@
               <a:spcAft>
                 <a:spcPts val="800"/>
               </a:spcAft>
-              <a:defRPr sz="1400" b="1">
+              <a:defRPr sz="1500" b="1">
                 <a:solidFill>
                   <a:srgbClr val="34D399"/>
                 </a:solidFill>
-              </a:defRPr>
-            </a:pPr>
-            <a:r>
-              <a:t>Standardized Enterprise REST API Surface  · [REST Contracts]</a:t>
-            </a:r>
-          </a:p>
-          <a:p>
-            <a:pPr>
-              <a:spcAft>
-                <a:spcPts val="500"/>
-              </a:spcAft>
-              <a:defRPr sz="1150">
-                <a:solidFill>
-                  <a:srgbClr val="F8FAFC"/>
-                </a:solidFill>
-              </a:defRPr>
-            </a:pPr>
-            <a:r>
-              <a:t>• Fully Typed Pydantic v2 REST Endpoints:</a:t>
-            </a:r>
-          </a:p>
-          <a:p>
-            <a:pPr>
-              <a:spcAft>
-                <a:spcPts val="500"/>
-              </a:spcAft>
-              <a:defRPr sz="1150">
-                <a:solidFill>
-                  <a:srgbClr val="F8FAFC"/>
-                </a:solidFill>
-              </a:defRPr>
-            </a:pPr>
-            <a:r>
-              <a:t>•    • POST /api/v1/documents/process — Ingests PDF/images, returns audit JSON.</a:t>
-            </a:r>
-          </a:p>
-          <a:p>
-            <a:pPr>
-              <a:spcAft>
-                <a:spcPts val="500"/>
-              </a:spcAft>
-              <a:defRPr sz="1150">
-                <a:solidFill>
-                  <a:srgbClr val="F8FAFC"/>
-                </a:solidFill>
-              </a:defRPr>
-            </a:pPr>
-            <a:r>
-              <a:t>•    • GET  /api/v1/documents — Paginated extraction history and metrics.</a:t>
-            </a:r>
-          </a:p>
-          <a:p>
-            <a:pPr>
-              <a:spcAft>
-                <a:spcPts val="500"/>
-              </a:spcAft>
-              <a:defRPr sz="1150">
-                <a:solidFill>
-                  <a:srgbClr val="F8FAFC"/>
-                </a:solidFill>
-              </a:defRPr>
-            </a:pPr>
-            <a:r>
-              <a:t>•    • GET  /api/v1/documents/{name} — Deep metadata &amp; provenance tree.</a:t>
-            </a:r>
-          </a:p>
-          <a:p>
-            <a:pPr>
-              <a:spcAft>
-                <a:spcPts val="500"/>
-              </a:spcAft>
-              <a:defRPr sz="1150">
-                <a:solidFill>
-                  <a:srgbClr val="F8FAFC"/>
-                </a:solidFill>
-              </a:defRPr>
-            </a:pPr>
-            <a:r>
-              <a:t>•    • GET  /health — JSON uptime, database ping, and service health.</a:t>
-            </a:r>
-          </a:p>
-          <a:p>
-            <a:pPr>
-              <a:spcAft>
-                <a:spcPts val="500"/>
-              </a:spcAft>
-              <a:defRPr sz="1150">
-                <a:solidFill>
-                  <a:srgbClr val="F8FAFC"/>
-                </a:solidFill>
+                <a:latin typeface="Times New Roman"/>
+              </a:defRPr>
+            </a:pPr>
+            <a:r>
+              <a:t>Scaling Blueprint to 10M Docs/Day &amp; Why I Win  · [Scale Blueprint]</a:t>
+            </a:r>
+          </a:p>
+          <a:p>
+            <a:pPr>
+              <a:spcAft>
+                <a:spcPts val="500"/>
+              </a:spcAft>
+              <a:defRPr sz="1200">
+                <a:solidFill>
+                  <a:srgbClr val="F8FAFC"/>
+                </a:solidFill>
+                <a:latin typeface="Times New Roman"/>
+              </a:defRPr>
+            </a:pPr>
+            <a:r>
+              <a:t>• Scaling Blueprint to 10 Million Documents / Day:</a:t>
+            </a:r>
+          </a:p>
+          <a:p>
+            <a:pPr>
+              <a:spcAft>
+                <a:spcPts val="500"/>
+              </a:spcAft>
+              <a:defRPr sz="1200">
+                <a:solidFill>
+                  <a:srgbClr val="F8FAFC"/>
+                </a:solidFill>
+                <a:latin typeface="Times New Roman"/>
+              </a:defRPr>
+            </a:pPr>
+            <a:r>
+              <a:t>•    1. Event-Driven Task Queue: Decouple FastAPI ingestion; stream to S3 and publish to Kafka.</a:t>
+            </a:r>
+          </a:p>
+          <a:p>
+            <a:pPr>
+              <a:spcAft>
+                <a:spcPts val="500"/>
+              </a:spcAft>
+              <a:defRPr sz="1200">
+                <a:solidFill>
+                  <a:srgbClr val="F8FAFC"/>
+                </a:solidFill>
+                <a:latin typeface="Times New Roman"/>
+              </a:defRPr>
+            </a:pPr>
+            <a:r>
+              <a:t>•    2. Auto-Scaling GPU Worker Fleet: ONNX Runtime with TensorRT on Kubernetes with KEDA.</a:t>
+            </a:r>
+          </a:p>
+          <a:p>
+            <a:pPr>
+              <a:spcAft>
+                <a:spcPts val="500"/>
+              </a:spcAft>
+              <a:defRPr sz="1200">
+                <a:solidFill>
+                  <a:srgbClr val="F8FAFC"/>
+                </a:solidFill>
+                <a:latin typeface="Times New Roman"/>
+              </a:defRPr>
+            </a:pPr>
+            <a:r>
+              <a:t>•    3. Partitioned Storage: PostgreSQL with TimescaleDB for financial time-series.</a:t>
+            </a:r>
+          </a:p>
+          <a:p>
+            <a:pPr>
+              <a:spcAft>
+                <a:spcPts val="500"/>
+              </a:spcAft>
+              <a:defRPr sz="1200">
+                <a:solidFill>
+                  <a:srgbClr val="F8FAFC"/>
+                </a:solidFill>
+                <a:latin typeface="Times New Roman"/>
               </a:defRPr>
             </a:pPr>
             <a:r>
@@ -8436,693 +8489,47 @@
               <a:spcAft>
                 <a:spcPts val="500"/>
               </a:spcAft>
-              <a:defRPr sz="1150">
-                <a:solidFill>
-                  <a:srgbClr val="F8FAFC"/>
-                </a:solidFill>
-              </a:defRPr>
-            </a:pPr>
-            <a:r>
-              <a:t>• Interactive OpenAPI Documentation:</a:t>
-            </a:r>
-          </a:p>
-          <a:p>
-            <a:pPr>
-              <a:spcAft>
-                <a:spcPts val="500"/>
-              </a:spcAft>
-              <a:defRPr sz="1150">
-                <a:solidFill>
-                  <a:srgbClr val="F8FAFC"/>
-                </a:solidFill>
-              </a:defRPr>
-            </a:pPr>
-            <a:r>
-              <a:t>•    • Swagger UI: https://doc-intel-financial-platform.onrender.com/docs</a:t>
-            </a:r>
-          </a:p>
-          <a:p>
-            <a:pPr>
-              <a:spcAft>
-                <a:spcPts val="500"/>
-              </a:spcAft>
-              <a:defRPr sz="1150">
-                <a:solidFill>
-                  <a:srgbClr val="F8FAFC"/>
-                </a:solidFill>
-              </a:defRPr>
-            </a:pPr>
-            <a:r>
-              <a:t>•    • ReDoc: https://doc-intel-financial-platform.onrender.com/redoc</a:t>
-            </a:r>
-          </a:p>
-          <a:p>
-            <a:pPr>
-              <a:spcAft>
-                <a:spcPts val="500"/>
-              </a:spcAft>
-              <a:defRPr sz="1150">
-                <a:solidFill>
-                  <a:srgbClr val="F8FAFC"/>
-                </a:solidFill>
-              </a:defRPr>
-            </a:pPr>
-            <a:r>
-              <a:t>•    • Built for instant plug-and-play integration into enterprise microservices.</a:t>
-            </a:r>
-          </a:p>
-        </p:txBody>
-      </p:sp>
-    </p:spTree>
-  </p:cSld>
-  <p:clrMapOvr>
-    <a:masterClrMapping/>
-  </p:clrMapOvr>
-</p:sld>
-</file>
-
-<file path=ppt/slides/slide9.xml><?xml version="1.0" encoding="utf-8"?>
-<p:sld xmlns:a="http://schemas.openxmlformats.org/drawingml/2006/main" xmlns:p="http://schemas.openxmlformats.org/presentationml/2006/main" xmlns:r="http://schemas.openxmlformats.org/officeDocument/2006/relationships">
-  <p:cSld>
-    <p:spTree>
-      <p:nvGrpSpPr>
-        <p:cNvPr id="1" name=""/>
-        <p:cNvGrpSpPr/>
-        <p:nvPr/>
-      </p:nvGrpSpPr>
-      <p:grpSpPr/>
-      <p:sp>
-        <p:nvSpPr>
-          <p:cNvPr id="2" name="Rectangle 1"/>
-          <p:cNvSpPr/>
-          <p:nvPr/>
-        </p:nvSpPr>
-        <p:spPr>
-          <a:xfrm>
-            <a:off x="0" y="0"/>
-            <a:ext cx="12191695" cy="6858000"/>
-          </a:xfrm>
-          <a:prstGeom prst="rect">
-            <a:avLst/>
-          </a:prstGeom>
-          <a:solidFill>
-            <a:srgbClr val="0A0E17"/>
-          </a:solidFill>
-          <a:ln>
-            <a:noFill/>
-          </a:ln>
-        </p:spPr>
-        <p:style>
-          <a:lnRef idx="1">
-            <a:schemeClr val="accent1"/>
-          </a:lnRef>
-          <a:fillRef idx="3">
-            <a:schemeClr val="accent1"/>
-          </a:fillRef>
-          <a:effectRef idx="2">
-            <a:schemeClr val="accent1"/>
-          </a:effectRef>
-          <a:fontRef idx="minor">
-            <a:schemeClr val="lt1"/>
-          </a:fontRef>
-        </p:style>
-        <p:txBody>
-          <a:bodyPr rtlCol="0" anchor="ctr"/>
-          <a:lstStyle/>
-          <a:p>
-            <a:pPr algn="ctr"/>
-          </a:p>
-        </p:txBody>
-      </p:sp>
-      <p:sp>
-        <p:nvSpPr>
-          <p:cNvPr id="3" name="Rounded Rectangle 2"/>
-          <p:cNvSpPr/>
-          <p:nvPr/>
-        </p:nvSpPr>
-        <p:spPr>
-          <a:xfrm>
-            <a:off x="731520" y="365760"/>
-            <a:ext cx="2560320" cy="292608"/>
-          </a:xfrm>
-          <a:prstGeom prst="roundRect">
-            <a:avLst/>
-          </a:prstGeom>
-          <a:solidFill>
-            <a:srgbClr val="1E3A8A"/>
-          </a:solidFill>
-          <a:ln>
-            <a:noFill/>
-          </a:ln>
-        </p:spPr>
-        <p:style>
-          <a:lnRef idx="1">
-            <a:schemeClr val="accent1"/>
-          </a:lnRef>
-          <a:fillRef idx="3">
-            <a:schemeClr val="accent1"/>
-          </a:fillRef>
-          <a:effectRef idx="2">
-            <a:schemeClr val="accent1"/>
-          </a:effectRef>
-          <a:fontRef idx="minor">
-            <a:schemeClr val="lt1"/>
-          </a:fontRef>
-        </p:style>
-        <p:txBody>
-          <a:bodyPr rtlCol="0" anchor="ctr"/>
-          <a:lstStyle/>
-          <a:p>
-            <a:pPr algn="ctr">
-              <a:defRPr sz="950" b="1">
-                <a:solidFill>
-                  <a:srgbClr val="93C5FD"/>
-                </a:solidFill>
-              </a:defRPr>
-            </a:pPr>
-            <a:r>
-              <a:t>PRODUCTION ROADMAP</a:t>
-            </a:r>
-          </a:p>
-        </p:txBody>
-      </p:sp>
-      <p:sp>
-        <p:nvSpPr>
-          <p:cNvPr id="4" name="TextBox 3"/>
-          <p:cNvSpPr txBox="1"/>
-          <p:nvPr/>
-        </p:nvSpPr>
-        <p:spPr>
-          <a:xfrm>
-            <a:off x="731520" y="685800"/>
-            <a:ext cx="9601200" cy="731520"/>
-          </a:xfrm>
-          <a:prstGeom prst="rect">
-            <a:avLst/>
-          </a:prstGeom>
-          <a:noFill/>
-        </p:spPr>
-        <p:txBody>
-          <a:bodyPr wrap="square">
-            <a:spAutoFit/>
-          </a:bodyPr>
-          <a:lstStyle/>
-          <a:p>
-            <a:pPr>
-              <a:defRPr sz="2100" b="1">
-                <a:solidFill>
-                  <a:srgbClr val="F8FAFC"/>
-                </a:solidFill>
-              </a:defRPr>
-            </a:pPr>
-            <a:r>
-              <a:t>Enterprise Scaling to 10M Docs/Day &amp; Candidate Summary</a:t>
-            </a:r>
-          </a:p>
-        </p:txBody>
-      </p:sp>
-      <p:sp>
-        <p:nvSpPr>
-          <p:cNvPr id="5" name="TextBox 4"/>
-          <p:cNvSpPr txBox="1"/>
-          <p:nvPr/>
-        </p:nvSpPr>
-        <p:spPr>
-          <a:xfrm>
-            <a:off x="10515600" y="365760"/>
-            <a:ext cx="914400" cy="365760"/>
-          </a:xfrm>
-          <a:prstGeom prst="rect">
-            <a:avLst/>
-          </a:prstGeom>
-          <a:noFill/>
-        </p:spPr>
-        <p:txBody>
-          <a:bodyPr wrap="none">
-            <a:spAutoFit/>
-          </a:bodyPr>
-          <a:lstStyle/>
-          <a:p>
-            <a:pPr algn="r">
-              <a:defRPr sz="1100" b="1">
-                <a:solidFill>
-                  <a:srgbClr val="94A3B8"/>
-                </a:solidFill>
-              </a:defRPr>
-            </a:pPr>
-            <a:r>
-              <a:t>09/09</a:t>
-            </a:r>
-          </a:p>
-        </p:txBody>
-      </p:sp>
-      <p:sp>
-        <p:nvSpPr>
-          <p:cNvPr id="6" name="Rounded Rectangle 5"/>
-          <p:cNvSpPr/>
-          <p:nvPr/>
-        </p:nvSpPr>
-        <p:spPr>
-          <a:xfrm>
-            <a:off x="731520" y="1554480"/>
-            <a:ext cx="5120640" cy="4754880"/>
-          </a:xfrm>
-          <a:prstGeom prst="roundRect">
-            <a:avLst/>
-          </a:prstGeom>
-          <a:solidFill>
-            <a:srgbClr val="141B2B"/>
-          </a:solidFill>
-          <a:ln w="15240">
-            <a:solidFill>
-              <a:srgbClr val="2D3A52"/>
-            </a:solidFill>
-          </a:ln>
-        </p:spPr>
-        <p:style>
-          <a:lnRef idx="1">
-            <a:schemeClr val="accent1"/>
-          </a:lnRef>
-          <a:fillRef idx="3">
-            <a:schemeClr val="accent1"/>
-          </a:fillRef>
-          <a:effectRef idx="2">
-            <a:schemeClr val="accent1"/>
-          </a:effectRef>
-          <a:fontRef idx="minor">
-            <a:schemeClr val="lt1"/>
-          </a:fontRef>
-        </p:style>
-        <p:txBody>
-          <a:bodyPr rtlCol="0" anchor="ctr"/>
-          <a:lstStyle/>
-          <a:p>
-            <a:pPr algn="ctr"/>
-          </a:p>
-        </p:txBody>
-      </p:sp>
-      <p:sp>
-        <p:nvSpPr>
-          <p:cNvPr id="7" name="TextBox 6"/>
-          <p:cNvSpPr txBox="1"/>
-          <p:nvPr/>
-        </p:nvSpPr>
-        <p:spPr>
-          <a:xfrm>
-            <a:off x="960120" y="1737360"/>
-            <a:ext cx="4663440" cy="4389120"/>
-          </a:xfrm>
-          <a:prstGeom prst="rect">
-            <a:avLst/>
-          </a:prstGeom>
-          <a:noFill/>
-        </p:spPr>
-        <p:txBody>
-          <a:bodyPr wrap="square">
-            <a:spAutoFit/>
-          </a:bodyPr>
-          <a:lstStyle/>
-          <a:p>
-            <a:pPr>
-              <a:spcAft>
-                <a:spcPts val="800"/>
-              </a:spcAft>
-              <a:defRPr sz="1400" b="1">
-                <a:solidFill>
-                  <a:srgbClr val="38BDF8"/>
-                </a:solidFill>
-              </a:defRPr>
-            </a:pPr>
-            <a:r>
-              <a:t>High-Scale Production Blueprint (10M Docs/Day)  · [10M Docs/Day]</a:t>
-            </a:r>
-          </a:p>
-          <a:p>
-            <a:pPr>
-              <a:spcAft>
-                <a:spcPts val="500"/>
-              </a:spcAft>
-              <a:defRPr sz="1150">
-                <a:solidFill>
-                  <a:srgbClr val="F8FAFC"/>
-                </a:solidFill>
-              </a:defRPr>
-            </a:pPr>
-            <a:r>
-              <a:t>• 1. Asynchronous Ingestion &amp; Distributed Event Bus:</a:t>
-            </a:r>
-          </a:p>
-          <a:p>
-            <a:pPr>
-              <a:spcAft>
-                <a:spcPts val="500"/>
-              </a:spcAft>
-              <a:defRPr sz="1150">
-                <a:solidFill>
-                  <a:srgbClr val="F8FAFC"/>
-                </a:solidFill>
-              </a:defRPr>
-            </a:pPr>
-            <a:r>
-              <a:t>•    • Decouple FastAPI ingestion from compute-heavy OCR.</a:t>
-            </a:r>
-          </a:p>
-          <a:p>
-            <a:pPr>
-              <a:spcAft>
-                <a:spcPts val="500"/>
-              </a:spcAft>
-              <a:defRPr sz="1150">
-                <a:solidFill>
-                  <a:srgbClr val="F8FAFC"/>
-                </a:solidFill>
-              </a:defRPr>
-            </a:pPr>
-            <a:r>
-              <a:t>•    • Ingest documents to Amazon S3 / Google Cloud Storage.</a:t>
-            </a:r>
-          </a:p>
-          <a:p>
-            <a:pPr>
-              <a:spcAft>
-                <a:spcPts val="500"/>
-              </a:spcAft>
-              <a:defRPr sz="1150">
-                <a:solidFill>
-                  <a:srgbClr val="F8FAFC"/>
-                </a:solidFill>
-              </a:defRPr>
-            </a:pPr>
-            <a:r>
-              <a:t>•    • Publish events to Apache Kafka or AWS SQS message queues.</a:t>
-            </a:r>
-          </a:p>
-          <a:p>
-            <a:pPr>
-              <a:spcAft>
-                <a:spcPts val="500"/>
-              </a:spcAft>
-              <a:defRPr sz="1150">
-                <a:solidFill>
-                  <a:srgbClr val="F8FAFC"/>
-                </a:solidFill>
-              </a:defRPr>
-            </a:pPr>
-            <a:r>
-              <a:t>• 2. Auto-scaling GPU Worker Fleet (Kubernetes / KEDA):</a:t>
-            </a:r>
-          </a:p>
-          <a:p>
-            <a:pPr>
-              <a:spcAft>
-                <a:spcPts val="500"/>
-              </a:spcAft>
-              <a:defRPr sz="1150">
-                <a:solidFill>
-                  <a:srgbClr val="F8FAFC"/>
-                </a:solidFill>
-              </a:defRPr>
-            </a:pPr>
-            <a:r>
-              <a:t>•    • Scale worker pods based on queue depth.</a:t>
-            </a:r>
-          </a:p>
-          <a:p>
-            <a:pPr>
-              <a:spcAft>
-                <a:spcPts val="500"/>
-              </a:spcAft>
-              <a:defRPr sz="1150">
-                <a:solidFill>
-                  <a:srgbClr val="F8FAFC"/>
-                </a:solidFill>
-              </a:defRPr>
-            </a:pPr>
-            <a:r>
-              <a:t>•    • Run ONNX Runtime with TensorRT execution provider on NVIDIA T4/A10G.</a:t>
-            </a:r>
-          </a:p>
-          <a:p>
-            <a:pPr>
-              <a:spcAft>
-                <a:spcPts val="500"/>
-              </a:spcAft>
-              <a:defRPr sz="1150">
-                <a:solidFill>
-                  <a:srgbClr val="F8FAFC"/>
-                </a:solidFill>
-              </a:defRPr>
-            </a:pPr>
-            <a:r>
-              <a:t>• 3. Partitioned Multi-Tier Persistence:</a:t>
-            </a:r>
-          </a:p>
-          <a:p>
-            <a:pPr>
-              <a:spcAft>
-                <a:spcPts val="500"/>
-              </a:spcAft>
-              <a:defRPr sz="1150">
-                <a:solidFill>
-                  <a:srgbClr val="F8FAFC"/>
-                </a:solidFill>
-              </a:defRPr>
-            </a:pPr>
-            <a:r>
-              <a:t>•    • Migrate SQLite to AWS Aurora PostgreSQL with TimescaleDB time-series.</a:t>
-            </a:r>
-          </a:p>
-          <a:p>
-            <a:pPr>
-              <a:spcAft>
-                <a:spcPts val="500"/>
-              </a:spcAft>
-              <a:defRPr sz="1150">
-                <a:solidFill>
-                  <a:srgbClr val="F8FAFC"/>
-                </a:solidFill>
-              </a:defRPr>
-            </a:pPr>
-            <a:r>
-              <a:t>•    • Redis cluster for caching frequently accessed financial entities.</a:t>
-            </a:r>
-          </a:p>
-        </p:txBody>
-      </p:sp>
-      <p:sp>
-        <p:nvSpPr>
-          <p:cNvPr id="8" name="Rounded Rectangle 7"/>
-          <p:cNvSpPr/>
-          <p:nvPr/>
-        </p:nvSpPr>
-        <p:spPr>
-          <a:xfrm>
-            <a:off x="6217920" y="1554480"/>
-            <a:ext cx="5120640" cy="4754880"/>
-          </a:xfrm>
-          <a:prstGeom prst="roundRect">
-            <a:avLst/>
-          </a:prstGeom>
-          <a:solidFill>
-            <a:srgbClr val="141B2B"/>
-          </a:solidFill>
-          <a:ln w="15240">
-            <a:solidFill>
-              <a:srgbClr val="2D3A52"/>
-            </a:solidFill>
-          </a:ln>
-        </p:spPr>
-        <p:style>
-          <a:lnRef idx="1">
-            <a:schemeClr val="accent1"/>
-          </a:lnRef>
-          <a:fillRef idx="3">
-            <a:schemeClr val="accent1"/>
-          </a:fillRef>
-          <a:effectRef idx="2">
-            <a:schemeClr val="accent1"/>
-          </a:effectRef>
-          <a:fontRef idx="minor">
-            <a:schemeClr val="lt1"/>
-          </a:fontRef>
-        </p:style>
-        <p:txBody>
-          <a:bodyPr rtlCol="0" anchor="ctr"/>
-          <a:lstStyle/>
-          <a:p>
-            <a:pPr algn="ctr"/>
-          </a:p>
-        </p:txBody>
-      </p:sp>
-      <p:sp>
-        <p:nvSpPr>
-          <p:cNvPr id="9" name="TextBox 8"/>
-          <p:cNvSpPr txBox="1"/>
-          <p:nvPr/>
-        </p:nvSpPr>
-        <p:spPr>
-          <a:xfrm>
-            <a:off x="6446520" y="1737360"/>
-            <a:ext cx="4663440" cy="4389120"/>
-          </a:xfrm>
-          <a:prstGeom prst="rect">
-            <a:avLst/>
-          </a:prstGeom>
-          <a:noFill/>
-        </p:spPr>
-        <p:txBody>
-          <a:bodyPr wrap="square">
-            <a:spAutoFit/>
-          </a:bodyPr>
-          <a:lstStyle/>
-          <a:p>
-            <a:pPr>
-              <a:spcAft>
-                <a:spcPts val="800"/>
-              </a:spcAft>
-              <a:defRPr sz="1400" b="1">
-                <a:solidFill>
-                  <a:srgbClr val="34D399"/>
-                </a:solidFill>
-              </a:defRPr>
-            </a:pPr>
-            <a:r>
-              <a:t>Why This Project Proves Senior Engineering Caliber  · [Summary]</a:t>
-            </a:r>
-          </a:p>
-          <a:p>
-            <a:pPr>
-              <a:spcAft>
-                <a:spcPts val="500"/>
-              </a:spcAft>
-              <a:defRPr sz="1150">
-                <a:solidFill>
-                  <a:srgbClr val="F8FAFC"/>
-                </a:solidFill>
-              </a:defRPr>
-            </a:pPr>
-            <a:r>
-              <a:t>• 1. Core Engineering over Superficial Wrappers:</a:t>
-            </a:r>
-          </a:p>
-          <a:p>
-            <a:pPr>
-              <a:spcAft>
-                <a:spcPts val="500"/>
-              </a:spcAft>
-              <a:defRPr sz="1150">
-                <a:solidFill>
-                  <a:srgbClr val="F8FAFC"/>
-                </a:solidFill>
-              </a:defRPr>
-            </a:pPr>
-            <a:r>
-              <a:t>•    • Built custom OCR pipelines, token clustering, and accounting engines instead of relying on basic third-party LLM API calls.</a:t>
-            </a:r>
-          </a:p>
-          <a:p>
-            <a:pPr>
-              <a:spcAft>
-                <a:spcPts val="500"/>
-              </a:spcAft>
-              <a:defRPr sz="1150">
-                <a:solidFill>
-                  <a:srgbClr val="F8FAFC"/>
-                </a:solidFill>
-              </a:defRPr>
-            </a:pPr>
-            <a:r>
-              <a:t>• </a:t>
-            </a:r>
-          </a:p>
-          <a:p>
-            <a:pPr>
-              <a:spcAft>
-                <a:spcPts val="500"/>
-              </a:spcAft>
-              <a:defRPr sz="1150">
-                <a:solidFill>
-                  <a:srgbClr val="F8FAFC"/>
-                </a:solidFill>
-              </a:defRPr>
-            </a:pPr>
-            <a:r>
-              <a:t>• 2. Real-World Robustness:</a:t>
-            </a:r>
-          </a:p>
-          <a:p>
-            <a:pPr>
-              <a:spcAft>
-                <a:spcPts val="500"/>
-              </a:spcAft>
-              <a:defRPr sz="1150">
-                <a:solidFill>
-                  <a:srgbClr val="F8FAFC"/>
-                </a:solidFill>
-              </a:defRPr>
-            </a:pPr>
-            <a:r>
-              <a:t>•    • Validated over 50 real-world documents with 100% extraction success.</a:t>
-            </a:r>
-          </a:p>
-          <a:p>
-            <a:pPr>
-              <a:spcAft>
-                <a:spcPts val="500"/>
-              </a:spcAft>
-              <a:defRPr sz="1150">
-                <a:solidFill>
-                  <a:srgbClr val="F8FAFC"/>
-                </a:solidFill>
-              </a:defRPr>
-            </a:pPr>
-            <a:r>
-              <a:t>•    • 10/10 passing automated Pytest tests, multi-stage Docker build.</a:t>
-            </a:r>
-          </a:p>
-          <a:p>
-            <a:pPr>
-              <a:spcAft>
-                <a:spcPts val="500"/>
-              </a:spcAft>
-              <a:defRPr sz="1150">
-                <a:solidFill>
-                  <a:srgbClr val="F8FAFC"/>
-                </a:solidFill>
-              </a:defRPr>
-            </a:pPr>
-            <a:r>
-              <a:t>•    • Deployed live on Render Cloud with active health probes.</a:t>
-            </a:r>
-          </a:p>
-          <a:p>
-            <a:pPr>
-              <a:spcAft>
-                <a:spcPts val="500"/>
-              </a:spcAft>
-              <a:defRPr sz="1150">
-                <a:solidFill>
-                  <a:srgbClr val="F8FAFC"/>
-                </a:solidFill>
-              </a:defRPr>
-            </a:pPr>
-            <a:r>
-              <a:t>• </a:t>
-            </a:r>
-          </a:p>
-          <a:p>
-            <a:pPr>
-              <a:spcAft>
-                <a:spcPts val="500"/>
-              </a:spcAft>
-              <a:defRPr sz="1150">
-                <a:solidFill>
-                  <a:srgbClr val="F8FAFC"/>
-                </a:solidFill>
-              </a:defRPr>
-            </a:pPr>
-            <a:r>
-              <a:t>• 3. Ready for Technical Deep Dive: Thank you! I welcome your questions.</a:t>
+              <a:defRPr sz="1200">
+                <a:solidFill>
+                  <a:srgbClr val="F8FAFC"/>
+                </a:solidFill>
+                <a:latin typeface="Times New Roman"/>
+              </a:defRPr>
+            </a:pPr>
+            <a:r>
+              <a:t>• Why This Candidate Wins for Neostats:</a:t>
+            </a:r>
+          </a:p>
+          <a:p>
+            <a:pPr>
+              <a:spcAft>
+                <a:spcPts val="500"/>
+              </a:spcAft>
+              <a:defRPr sz="1200">
+                <a:solidFill>
+                  <a:srgbClr val="F8FAFC"/>
+                </a:solidFill>
+                <a:latin typeface="Times New Roman"/>
+              </a:defRPr>
+            </a:pPr>
+            <a:r>
+              <a:t>•    • Core Engineering over Toy Wrappers: Built custom OCR and accounting engines.</a:t>
+            </a:r>
+          </a:p>
+          <a:p>
+            <a:pPr>
+              <a:spcAft>
+                <a:spcPts val="500"/>
+              </a:spcAft>
+              <a:defRPr sz="1200">
+                <a:solidFill>
+                  <a:srgbClr val="F8FAFC"/>
+                </a:solidFill>
+                <a:latin typeface="Times New Roman"/>
+              </a:defRPr>
+            </a:pPr>
+            <a:r>
+              <a:t>•    • Production Rigor: 50 documents benchmarked, 10 passing tests, live cloud deployment.</a:t>
             </a:r>
           </a:p>
         </p:txBody>

</xml_diff>